<commit_message>
Update intrusion detection project assets
</commit_message>
<xml_diff>
--- a/SCOPE_SDP_Template_May_2026.pptx
+++ b/SCOPE_SDP_Template_May_2026.pptx
@@ -5,7 +5,7 @@
     <p:sldMasterId id="2147483648" r:id="rId1"/>
   </p:sldMasterIdLst>
   <p:notesMasterIdLst>
-    <p:notesMasterId r:id="rId18"/>
+    <p:notesMasterId r:id="rId16"/>
   </p:notesMasterIdLst>
   <p:sldIdLst>
     <p:sldId id="256" r:id="rId2"/>
@@ -13,17 +13,15 @@
     <p:sldId id="258" r:id="rId4"/>
     <p:sldId id="265" r:id="rId5"/>
     <p:sldId id="259" r:id="rId6"/>
-    <p:sldId id="267" r:id="rId7"/>
-    <p:sldId id="275" r:id="rId8"/>
-    <p:sldId id="268" r:id="rId9"/>
-    <p:sldId id="269" r:id="rId10"/>
-    <p:sldId id="270" r:id="rId11"/>
-    <p:sldId id="271" r:id="rId12"/>
-    <p:sldId id="272" r:id="rId13"/>
-    <p:sldId id="273" r:id="rId14"/>
-    <p:sldId id="274" r:id="rId15"/>
-    <p:sldId id="264" r:id="rId16"/>
-    <p:sldId id="263" r:id="rId17"/>
+    <p:sldId id="275" r:id="rId7"/>
+    <p:sldId id="269" r:id="rId8"/>
+    <p:sldId id="270" r:id="rId9"/>
+    <p:sldId id="271" r:id="rId10"/>
+    <p:sldId id="272" r:id="rId11"/>
+    <p:sldId id="273" r:id="rId12"/>
+    <p:sldId id="274" r:id="rId13"/>
+    <p:sldId id="264" r:id="rId14"/>
+    <p:sldId id="263" r:id="rId15"/>
   </p:sldIdLst>
   <p:sldSz cx="12192000" cy="6858000"/>
   <p:notesSz cx="6858000" cy="9144000"/>
@@ -450,7 +448,7 @@
           <a:p>
             <a:fld id="{1C7A9119-8600-41C0-9D23-A09797EEA137}" type="datetimeFigureOut">
               <a:rPr lang="en-IN" smtClean="0"/>
-              <a:t>03-05-2026</a:t>
+              <a:t>27-06-2026</a:t>
             </a:fld>
             <a:endParaRPr lang="en-IN"/>
           </a:p>
@@ -867,7 +865,7 @@
           <a:p>
             <a:fld id="{AB013622-15DD-42DB-94A2-CC190AAE8F19}" type="slidenum">
               <a:rPr lang="en-IN" smtClean="0"/>
-              <a:t>14</a:t>
+              <a:t>12</a:t>
             </a:fld>
             <a:endParaRPr lang="en-IN"/>
           </a:p>
@@ -1035,7 +1033,7 @@
           <a:p>
             <a:fld id="{F4AA9AC0-57E6-4806-9FC7-7423DB7F4C34}" type="datetimeFigureOut">
               <a:rPr lang="en-IN" smtClean="0"/>
-              <a:t>03-05-2026</a:t>
+              <a:t>27-06-2026</a:t>
             </a:fld>
             <a:endParaRPr lang="en-IN"/>
           </a:p>
@@ -1235,7 +1233,7 @@
           <a:p>
             <a:fld id="{F4AA9AC0-57E6-4806-9FC7-7423DB7F4C34}" type="datetimeFigureOut">
               <a:rPr lang="en-IN" smtClean="0"/>
-              <a:t>03-05-2026</a:t>
+              <a:t>27-06-2026</a:t>
             </a:fld>
             <a:endParaRPr lang="en-IN"/>
           </a:p>
@@ -1445,7 +1443,7 @@
           <a:p>
             <a:fld id="{F4AA9AC0-57E6-4806-9FC7-7423DB7F4C34}" type="datetimeFigureOut">
               <a:rPr lang="en-IN" smtClean="0"/>
-              <a:t>03-05-2026</a:t>
+              <a:t>27-06-2026</a:t>
             </a:fld>
             <a:endParaRPr lang="en-IN"/>
           </a:p>
@@ -2073,7 +2071,7 @@
           <a:p>
             <a:fld id="{F4AA9AC0-57E6-4806-9FC7-7423DB7F4C34}" type="datetimeFigureOut">
               <a:rPr lang="en-IN" smtClean="0"/>
-              <a:t>03-05-2026</a:t>
+              <a:t>27-06-2026</a:t>
             </a:fld>
             <a:endParaRPr lang="en-IN"/>
           </a:p>
@@ -2349,7 +2347,7 @@
           <a:p>
             <a:fld id="{F4AA9AC0-57E6-4806-9FC7-7423DB7F4C34}" type="datetimeFigureOut">
               <a:rPr lang="en-IN" smtClean="0"/>
-              <a:t>03-05-2026</a:t>
+              <a:t>27-06-2026</a:t>
             </a:fld>
             <a:endParaRPr lang="en-IN"/>
           </a:p>
@@ -2617,7 +2615,7 @@
           <a:p>
             <a:fld id="{F4AA9AC0-57E6-4806-9FC7-7423DB7F4C34}" type="datetimeFigureOut">
               <a:rPr lang="en-IN" smtClean="0"/>
-              <a:t>03-05-2026</a:t>
+              <a:t>27-06-2026</a:t>
             </a:fld>
             <a:endParaRPr lang="en-IN"/>
           </a:p>
@@ -3032,7 +3030,7 @@
           <a:p>
             <a:fld id="{F4AA9AC0-57E6-4806-9FC7-7423DB7F4C34}" type="datetimeFigureOut">
               <a:rPr lang="en-IN" smtClean="0"/>
-              <a:t>03-05-2026</a:t>
+              <a:t>27-06-2026</a:t>
             </a:fld>
             <a:endParaRPr lang="en-IN"/>
           </a:p>
@@ -3174,7 +3172,7 @@
           <a:p>
             <a:fld id="{F4AA9AC0-57E6-4806-9FC7-7423DB7F4C34}" type="datetimeFigureOut">
               <a:rPr lang="en-IN" smtClean="0"/>
-              <a:t>03-05-2026</a:t>
+              <a:t>27-06-2026</a:t>
             </a:fld>
             <a:endParaRPr lang="en-IN"/>
           </a:p>
@@ -3287,7 +3285,7 @@
           <a:p>
             <a:fld id="{F4AA9AC0-57E6-4806-9FC7-7423DB7F4C34}" type="datetimeFigureOut">
               <a:rPr lang="en-IN" smtClean="0"/>
-              <a:t>03-05-2026</a:t>
+              <a:t>27-06-2026</a:t>
             </a:fld>
             <a:endParaRPr lang="en-IN"/>
           </a:p>
@@ -3600,7 +3598,7 @@
           <a:p>
             <a:fld id="{F4AA9AC0-57E6-4806-9FC7-7423DB7F4C34}" type="datetimeFigureOut">
               <a:rPr lang="en-IN" smtClean="0"/>
-              <a:t>03-05-2026</a:t>
+              <a:t>27-06-2026</a:t>
             </a:fld>
             <a:endParaRPr lang="en-IN"/>
           </a:p>
@@ -3889,7 +3887,7 @@
           <a:p>
             <a:fld id="{F4AA9AC0-57E6-4806-9FC7-7423DB7F4C34}" type="datetimeFigureOut">
               <a:rPr lang="en-IN" smtClean="0"/>
-              <a:t>03-05-2026</a:t>
+              <a:t>27-06-2026</a:t>
             </a:fld>
             <a:endParaRPr lang="en-IN"/>
           </a:p>
@@ -4132,7 +4130,7 @@
           <a:p>
             <a:fld id="{F4AA9AC0-57E6-4806-9FC7-7423DB7F4C34}" type="datetimeFigureOut">
               <a:rPr lang="en-IN" smtClean="0"/>
-              <a:t>03-05-2026</a:t>
+              <a:t>27-06-2026</a:t>
             </a:fld>
             <a:endParaRPr lang="en-IN"/>
           </a:p>
@@ -4638,7 +4636,7 @@
                 </a:solidFill>
                 <a:latin typeface="Arial Narrow" panose="020B0606020202030204" pitchFamily="34" charset="0"/>
               </a:rPr>
-              <a:t>[Title of the Project]</a:t>
+              <a:t>[NETWORK INTRUSION DETECTION SYSTEM]</a:t>
             </a:r>
             <a:endParaRPr lang="en-US" sz="3733" b="1" spc="-1" dirty="0">
               <a:solidFill>
@@ -4688,7 +4686,7 @@
                 <a:ea typeface="Calibri" panose="020F0502020204030204" pitchFamily="34" charset="0"/>
                 <a:cs typeface="Calibri" panose="020F0502020204030204" pitchFamily="34" charset="0"/>
               </a:rPr>
-              <a:t>SDP ID:</a:t>
+              <a:t>SDP ID: 20260059</a:t>
             </a:r>
             <a:endParaRPr lang="en-IN" sz="2400" spc="-1" dirty="0">
               <a:solidFill>
@@ -4709,8 +4707,8 @@
         </p:nvSpPr>
         <p:spPr>
           <a:xfrm>
-            <a:off x="311259" y="2808341"/>
-            <a:ext cx="4896544" cy="2419750"/>
+            <a:off x="311258" y="2808341"/>
+            <a:ext cx="7708029" cy="2994394"/>
           </a:xfrm>
           <a:prstGeom prst="rect">
             <a:avLst/>
@@ -4773,8 +4771,33 @@
                 <a:ea typeface="Calibri" panose="020F0502020204030204" pitchFamily="34" charset="0"/>
                 <a:cs typeface="Calibri" panose="020F0502020204030204" pitchFamily="34" charset="0"/>
               </a:rPr>
-              <a:t>Name of the Student(s) with Regd. No.:</a:t>
-            </a:r>
+              <a:t>SYED SIBGHATULLAH (22BCE7601)</a:t>
+            </a:r>
+          </a:p>
+          <a:p>
+            <a:pPr>
+              <a:lnSpc>
+                <a:spcPct val="100000"/>
+              </a:lnSpc>
+            </a:pPr>
+            <a:r>
+              <a:rPr lang="en-IN" sz="1867" b="1" spc="-1" dirty="0">
+                <a:solidFill>
+                  <a:srgbClr val="000000"/>
+                </a:solidFill>
+                <a:latin typeface="Calibri" panose="020F0502020204030204" pitchFamily="34" charset="0"/>
+                <a:ea typeface="Calibri" panose="020F0502020204030204" pitchFamily="34" charset="0"/>
+                <a:cs typeface="Calibri" panose="020F0502020204030204" pitchFamily="34" charset="0"/>
+              </a:rPr>
+              <a:t>SANDEEP MOORTHY (22BCE8664)</a:t>
+            </a:r>
+          </a:p>
+          <a:p>
+            <a:pPr>
+              <a:lnSpc>
+                <a:spcPct val="100000"/>
+              </a:lnSpc>
+            </a:pPr>
             <a:endParaRPr lang="en-IN" sz="1867" spc="-1" dirty="0">
               <a:latin typeface="Calibri" panose="020F0502020204030204" pitchFamily="34" charset="0"/>
               <a:ea typeface="Calibri" panose="020F0502020204030204" pitchFamily="34" charset="0"/>
@@ -5033,6 +5056,13 @@
           </a:effectRef>
           <a:fontRef idx="minor"/>
         </p:style>
+        <p:txBody>
+          <a:bodyPr/>
+          <a:lstStyle/>
+          <a:p>
+            <a:endParaRPr lang="en-US"/>
+          </a:p>
+        </p:txBody>
       </p:sp>
       <p:pic>
         <p:nvPicPr>
@@ -5086,7 +5116,7 @@
         <p:cNvPr id="1" name="">
           <a:extLst>
             <a:ext uri="{FF2B5EF4-FFF2-40B4-BE49-F238E27FC236}">
-              <a16:creationId xmlns:a16="http://schemas.microsoft.com/office/drawing/2014/main" id="{1430AD02-BE5E-1467-2150-90B5D7403CC8}"/>
+              <a16:creationId xmlns:a16="http://schemas.microsoft.com/office/drawing/2014/main" id="{3147A995-01EF-3BFB-7823-ADBBEBB2F4D7}"/>
             </a:ext>
           </a:extLst>
         </p:cNvPr>
@@ -5106,7 +5136,7 @@
           <p:cNvPr id="109" name="TextShape 1">
             <a:extLst>
               <a:ext uri="{FF2B5EF4-FFF2-40B4-BE49-F238E27FC236}">
-                <a16:creationId xmlns:a16="http://schemas.microsoft.com/office/drawing/2014/main" id="{AFE7C81F-6E58-2367-107E-6694BBFC4019}"/>
+                <a16:creationId xmlns:a16="http://schemas.microsoft.com/office/drawing/2014/main" id="{9538C986-A499-4BC7-0FC4-41C7F2F0E21A}"/>
               </a:ext>
             </a:extLst>
           </p:cNvPr>
@@ -5149,7 +5179,7 @@
                 <a:ea typeface="Calibri" panose="020F0502020204030204" pitchFamily="34" charset="0"/>
                 <a:cs typeface="Calibri" panose="020F0502020204030204" pitchFamily="34" charset="0"/>
               </a:rPr>
-              <a:t>Proposed Solution</a:t>
+              <a:t>Simulation and Results </a:t>
             </a:r>
             <a:br>
               <a:rPr lang="en-US" sz="7066" b="1" spc="-1" dirty="0">
@@ -5175,7 +5205,7 @@
           <p:cNvPr id="110" name="TextShape 2">
             <a:extLst>
               <a:ext uri="{FF2B5EF4-FFF2-40B4-BE49-F238E27FC236}">
-                <a16:creationId xmlns:a16="http://schemas.microsoft.com/office/drawing/2014/main" id="{9C105956-1DE0-D7E6-B955-48A1A17A560C}"/>
+                <a16:creationId xmlns:a16="http://schemas.microsoft.com/office/drawing/2014/main" id="{B2CA8E46-881A-8416-8683-D5ED614CAA5C}"/>
               </a:ext>
             </a:extLst>
           </p:cNvPr>
@@ -5184,7 +5214,7 @@
         </p:nvSpPr>
         <p:spPr>
           <a:xfrm>
-            <a:off x="291560" y="740701"/>
+            <a:off x="305820" y="740701"/>
             <a:ext cx="11193400" cy="4812680"/>
           </a:xfrm>
           <a:prstGeom prst="rect">
@@ -5216,12 +5246,31 @@
                 <a:solidFill>
                   <a:srgbClr val="000000"/>
                 </a:solidFill>
+                <a:latin typeface="Gill Sans MT"/>
+              </a:rPr>
+              <a:t> </a:t>
+            </a:r>
+            <a:r>
+              <a:rPr lang="en-US" sz="2667" b="1" spc="-1" dirty="0">
+                <a:solidFill>
+                  <a:srgbClr val="000000"/>
+                </a:solidFill>
                 <a:latin typeface="Calibri" panose="020F0502020204030204" pitchFamily="34" charset="0"/>
                 <a:ea typeface="Calibri" panose="020F0502020204030204" pitchFamily="34" charset="0"/>
                 <a:cs typeface="Calibri" panose="020F0502020204030204" pitchFamily="34" charset="0"/>
               </a:rPr>
-              <a:t>Algorithms / Technologies, Frameworks, and Tools Used</a:t>
-            </a:r>
+              <a:t>Parameters Descriptions (if any) / Initial Conditions</a:t>
+            </a:r>
+          </a:p>
+          <a:p>
+            <a:endParaRPr lang="en-US" sz="3200" spc="-1" dirty="0">
+              <a:solidFill>
+                <a:srgbClr val="000000"/>
+              </a:solidFill>
+              <a:latin typeface="Calibri" panose="020F0502020204030204" pitchFamily="34" charset="0"/>
+              <a:ea typeface="Calibri" panose="020F0502020204030204" pitchFamily="34" charset="0"/>
+              <a:cs typeface="Calibri" panose="020F0502020204030204" pitchFamily="34" charset="0"/>
+            </a:endParaRPr>
           </a:p>
           <a:p>
             <a:endParaRPr lang="en-US" sz="3200" spc="-1" dirty="0">
@@ -5232,6 +5281,11 @@
             </a:endParaRPr>
           </a:p>
           <a:p>
+            <a:pPr marL="536627">
+              <a:spcBef>
+                <a:spcPts val="733"/>
+              </a:spcBef>
+            </a:pPr>
             <a:endParaRPr lang="en-US" sz="3200" spc="-1" dirty="0">
               <a:solidFill>
                 <a:srgbClr val="000000"/>
@@ -5240,9 +5294,9 @@
             </a:endParaRPr>
           </a:p>
           <a:p>
-            <a:pPr marL="536627">
+            <a:pPr marL="109917">
               <a:spcBef>
-                <a:spcPts val="733"/>
+                <a:spcPts val="801"/>
               </a:spcBef>
             </a:pPr>
             <a:endParaRPr lang="en-US" sz="3200" spc="-1" dirty="0">
@@ -5252,19 +5306,6 @@
               <a:latin typeface="Gill Sans MT"/>
             </a:endParaRPr>
           </a:p>
-          <a:p>
-            <a:pPr marL="109917">
-              <a:spcBef>
-                <a:spcPts val="801"/>
-              </a:spcBef>
-            </a:pPr>
-            <a:endParaRPr lang="en-US" sz="3200" spc="-1" dirty="0">
-              <a:solidFill>
-                <a:srgbClr val="000000"/>
-              </a:solidFill>
-              <a:latin typeface="Gill Sans MT"/>
-            </a:endParaRPr>
-          </a:p>
         </p:txBody>
       </p:sp>
       <p:sp>
@@ -5272,7 +5313,7 @@
           <p:cNvPr id="111" name="TextShape 3">
             <a:extLst>
               <a:ext uri="{FF2B5EF4-FFF2-40B4-BE49-F238E27FC236}">
-                <a16:creationId xmlns:a16="http://schemas.microsoft.com/office/drawing/2014/main" id="{F4BC6724-9707-184F-3066-39F40243A6B0}"/>
+                <a16:creationId xmlns:a16="http://schemas.microsoft.com/office/drawing/2014/main" id="{8F31D5F8-9576-A840-BF26-6AA4B120CB3B}"/>
               </a:ext>
             </a:extLst>
           </p:cNvPr>
@@ -5316,605 +5357,6 @@
                 </a:lnSpc>
               </a:pPr>
               <a:t>10</a:t>
-            </a:fld>
-            <a:endParaRPr lang="en-IN" sz="1600" spc="-1">
-              <a:latin typeface="Times New Roman"/>
-            </a:endParaRPr>
-          </a:p>
-        </p:txBody>
-      </p:sp>
-      <p:pic>
-        <p:nvPicPr>
-          <p:cNvPr id="3" name="Picture 2">
-            <a:extLst>
-              <a:ext uri="{FF2B5EF4-FFF2-40B4-BE49-F238E27FC236}">
-                <a16:creationId xmlns:a16="http://schemas.microsoft.com/office/drawing/2014/main" id="{4115297C-41A1-D3DE-E0E5-215AC0FFA2FD}"/>
-              </a:ext>
-            </a:extLst>
-          </p:cNvPr>
-          <p:cNvPicPr>
-            <a:picLocks noChangeAspect="1"/>
-          </p:cNvPicPr>
-          <p:nvPr/>
-        </p:nvPicPr>
-        <p:blipFill>
-          <a:blip r:embed="rId2">
-            <a:extLst>
-              <a:ext uri="{28A0092B-C50C-407E-A947-70E740481C1C}">
-                <a14:useLocalDpi xmlns:a14="http://schemas.microsoft.com/office/drawing/2010/main" val="0"/>
-              </a:ext>
-            </a:extLst>
-          </a:blip>
-          <a:stretch>
-            <a:fillRect/>
-          </a:stretch>
-        </p:blipFill>
-        <p:spPr>
-          <a:xfrm>
-            <a:off x="10032437" y="160201"/>
-            <a:ext cx="2035376" cy="516641"/>
-          </a:xfrm>
-          <a:prstGeom prst="rect">
-            <a:avLst/>
-          </a:prstGeom>
-        </p:spPr>
-      </p:pic>
-    </p:spTree>
-    <p:extLst>
-      <p:ext uri="{BB962C8B-B14F-4D97-AF65-F5344CB8AC3E}">
-        <p14:creationId xmlns:p14="http://schemas.microsoft.com/office/powerpoint/2010/main" val="3267501494"/>
-      </p:ext>
-    </p:extLst>
-  </p:cSld>
-  <p:clrMapOvr>
-    <a:masterClrMapping/>
-  </p:clrMapOvr>
-</p:sld>
-</file>
-
-<file path=ppt/slides/slide11.xml><?xml version="1.0" encoding="utf-8"?>
-<p:sld xmlns:a="http://schemas.openxmlformats.org/drawingml/2006/main" xmlns:r="http://schemas.openxmlformats.org/officeDocument/2006/relationships" xmlns:p="http://schemas.openxmlformats.org/presentationml/2006/main">
-  <p:cSld>
-    <p:spTree>
-      <p:nvGrpSpPr>
-        <p:cNvPr id="1" name="">
-          <a:extLst>
-            <a:ext uri="{FF2B5EF4-FFF2-40B4-BE49-F238E27FC236}">
-              <a16:creationId xmlns:a16="http://schemas.microsoft.com/office/drawing/2014/main" id="{43892C97-F36E-BCB4-699E-2D8162180958}"/>
-            </a:ext>
-          </a:extLst>
-        </p:cNvPr>
-        <p:cNvGrpSpPr/>
-        <p:nvPr/>
-      </p:nvGrpSpPr>
-      <p:grpSpPr>
-        <a:xfrm>
-          <a:off x="0" y="0"/>
-          <a:ext cx="0" cy="0"/>
-          <a:chOff x="0" y="0"/>
-          <a:chExt cx="0" cy="0"/>
-        </a:xfrm>
-      </p:grpSpPr>
-      <p:sp>
-        <p:nvSpPr>
-          <p:cNvPr id="109" name="TextShape 1">
-            <a:extLst>
-              <a:ext uri="{FF2B5EF4-FFF2-40B4-BE49-F238E27FC236}">
-                <a16:creationId xmlns:a16="http://schemas.microsoft.com/office/drawing/2014/main" id="{92160046-EB52-CD90-37C0-AFB11476B9CB}"/>
-              </a:ext>
-            </a:extLst>
-          </p:cNvPr>
-          <p:cNvSpPr txBox="1"/>
-          <p:nvPr/>
-        </p:nvSpPr>
-        <p:spPr>
-          <a:xfrm>
-            <a:off x="279555" y="76681"/>
-            <a:ext cx="11053987" cy="979439"/>
-          </a:xfrm>
-          <a:prstGeom prst="rect">
-            <a:avLst/>
-          </a:prstGeom>
-          <a:noFill/>
-          <a:ln>
-            <a:noFill/>
-          </a:ln>
-        </p:spPr>
-        <p:txBody>
-          <a:bodyPr lIns="120000" tIns="60000" rIns="120000" bIns="60000" anchor="ctr">
-            <a:normAutofit fontScale="40000" lnSpcReduction="20000"/>
-          </a:bodyPr>
-          <a:lstStyle/>
-          <a:p>
-            <a:pPr>
-              <a:lnSpc>
-                <a:spcPct val="100000"/>
-              </a:lnSpc>
-            </a:pPr>
-            <a:br>
-              <a:rPr sz="2400" dirty="0"/>
-            </a:br>
-            <a:r>
-              <a:rPr lang="en-US" sz="7866" b="1" spc="-1" dirty="0">
-                <a:solidFill>
-                  <a:srgbClr val="8A0000"/>
-                </a:solidFill>
-                <a:latin typeface="Calibri" panose="020F0502020204030204" pitchFamily="34" charset="0"/>
-                <a:ea typeface="Calibri" panose="020F0502020204030204" pitchFamily="34" charset="0"/>
-                <a:cs typeface="Calibri" panose="020F0502020204030204" pitchFamily="34" charset="0"/>
-              </a:rPr>
-              <a:t>Simulation and Results</a:t>
-            </a:r>
-            <a:br>
-              <a:rPr lang="en-US" sz="7066" b="1" spc="-1" dirty="0">
-                <a:solidFill>
-                  <a:srgbClr val="8A0000"/>
-                </a:solidFill>
-                <a:latin typeface="Times New Roman" pitchFamily="18" charset="0"/>
-                <a:cs typeface="Times New Roman" pitchFamily="18" charset="0"/>
-              </a:rPr>
-            </a:br>
-            <a:endParaRPr lang="en-US" sz="7066" b="1" spc="-1" dirty="0">
-              <a:solidFill>
-                <a:srgbClr val="8A0000"/>
-              </a:solidFill>
-              <a:latin typeface="Times New Roman" pitchFamily="18" charset="0"/>
-              <a:cs typeface="Times New Roman" pitchFamily="18" charset="0"/>
-            </a:endParaRPr>
-          </a:p>
-        </p:txBody>
-      </p:sp>
-      <p:sp>
-        <p:nvSpPr>
-          <p:cNvPr id="110" name="TextShape 2">
-            <a:extLst>
-              <a:ext uri="{FF2B5EF4-FFF2-40B4-BE49-F238E27FC236}">
-                <a16:creationId xmlns:a16="http://schemas.microsoft.com/office/drawing/2014/main" id="{7F3FF00A-8B20-B862-1391-CAE97E4165AE}"/>
-              </a:ext>
-            </a:extLst>
-          </p:cNvPr>
-          <p:cNvSpPr txBox="1"/>
-          <p:nvPr/>
-        </p:nvSpPr>
-        <p:spPr>
-          <a:xfrm>
-            <a:off x="305820" y="740701"/>
-            <a:ext cx="11193400" cy="4812680"/>
-          </a:xfrm>
-          <a:prstGeom prst="rect">
-            <a:avLst/>
-          </a:prstGeom>
-          <a:noFill/>
-          <a:ln>
-            <a:noFill/>
-          </a:ln>
-        </p:spPr>
-        <p:txBody>
-          <a:bodyPr lIns="120000" tIns="60000" rIns="120000" bIns="60000">
-            <a:noAutofit/>
-          </a:bodyPr>
-          <a:lstStyle/>
-          <a:p>
-            <a:pPr marL="384710" indent="-457189">
-              <a:spcBef>
-                <a:spcPts val="733"/>
-              </a:spcBef>
-              <a:buClr>
-                <a:srgbClr val="C00000"/>
-              </a:buClr>
-              <a:buFont typeface="Wingdings" panose="05000000000000000000" pitchFamily="2" charset="2"/>
-              <a:buChar char="q"/>
-            </a:pPr>
-            <a:r>
-              <a:rPr lang="en-US" sz="2667" b="1" spc="-1" dirty="0">
-                <a:solidFill>
-                  <a:srgbClr val="000000"/>
-                </a:solidFill>
-                <a:latin typeface="Calibri" panose="020F0502020204030204" pitchFamily="34" charset="0"/>
-                <a:ea typeface="Calibri" panose="020F0502020204030204" pitchFamily="34" charset="0"/>
-                <a:cs typeface="Calibri" panose="020F0502020204030204" pitchFamily="34" charset="0"/>
-              </a:rPr>
-              <a:t>Dataset Descriptions / Input – Output Descriptions</a:t>
-            </a:r>
-          </a:p>
-          <a:p>
-            <a:endParaRPr lang="en-US" sz="3200" spc="-1" dirty="0">
-              <a:solidFill>
-                <a:srgbClr val="000000"/>
-              </a:solidFill>
-              <a:latin typeface="Gill Sans MT"/>
-            </a:endParaRPr>
-          </a:p>
-          <a:p>
-            <a:endParaRPr lang="en-US" sz="3200" spc="-1" dirty="0">
-              <a:solidFill>
-                <a:srgbClr val="000000"/>
-              </a:solidFill>
-              <a:latin typeface="Gill Sans MT"/>
-            </a:endParaRPr>
-          </a:p>
-          <a:p>
-            <a:pPr marL="536627">
-              <a:spcBef>
-                <a:spcPts val="733"/>
-              </a:spcBef>
-            </a:pPr>
-            <a:endParaRPr lang="en-US" sz="3200" spc="-1" dirty="0">
-              <a:solidFill>
-                <a:srgbClr val="000000"/>
-              </a:solidFill>
-              <a:latin typeface="Gill Sans MT"/>
-            </a:endParaRPr>
-          </a:p>
-          <a:p>
-            <a:pPr marL="109917">
-              <a:spcBef>
-                <a:spcPts val="801"/>
-              </a:spcBef>
-            </a:pPr>
-            <a:endParaRPr lang="en-US" sz="3200" spc="-1" dirty="0">
-              <a:solidFill>
-                <a:srgbClr val="000000"/>
-              </a:solidFill>
-              <a:latin typeface="Gill Sans MT"/>
-            </a:endParaRPr>
-          </a:p>
-        </p:txBody>
-      </p:sp>
-      <p:sp>
-        <p:nvSpPr>
-          <p:cNvPr id="111" name="TextShape 3">
-            <a:extLst>
-              <a:ext uri="{FF2B5EF4-FFF2-40B4-BE49-F238E27FC236}">
-                <a16:creationId xmlns:a16="http://schemas.microsoft.com/office/drawing/2014/main" id="{64EDF79D-8D5B-6AFF-0EA3-42D35D8BD3BA}"/>
-              </a:ext>
-            </a:extLst>
-          </p:cNvPr>
-          <p:cNvSpPr txBox="1"/>
-          <p:nvPr/>
-        </p:nvSpPr>
-        <p:spPr>
-          <a:xfrm>
-            <a:off x="11484960" y="6305400"/>
-            <a:ext cx="609120" cy="475920"/>
-          </a:xfrm>
-          <a:prstGeom prst="rect">
-            <a:avLst/>
-          </a:prstGeom>
-          <a:noFill/>
-          <a:ln>
-            <a:noFill/>
-          </a:ln>
-        </p:spPr>
-        <p:txBody>
-          <a:bodyPr lIns="120000" tIns="60000" rIns="120000" bIns="60000" anchor="b">
-            <a:noAutofit/>
-          </a:bodyPr>
-          <a:lstStyle/>
-          <a:p>
-            <a:pPr algn="ctr">
-              <a:lnSpc>
-                <a:spcPct val="100000"/>
-              </a:lnSpc>
-            </a:pPr>
-            <a:fld id="{528F5C0C-45A4-465E-8315-A9258DDEFD0F}" type="slidenum">
-              <a:rPr lang="en-IN" sz="1600" spc="-1">
-                <a:solidFill>
-                  <a:srgbClr val="B5A989"/>
-                </a:solidFill>
-                <a:latin typeface="Gill Sans MT"/>
-              </a:rPr>
-              <a:pPr algn="ctr">
-                <a:lnSpc>
-                  <a:spcPct val="100000"/>
-                </a:lnSpc>
-              </a:pPr>
-              <a:t>11</a:t>
-            </a:fld>
-            <a:endParaRPr lang="en-IN" sz="1600" spc="-1">
-              <a:latin typeface="Times New Roman"/>
-            </a:endParaRPr>
-          </a:p>
-        </p:txBody>
-      </p:sp>
-      <p:pic>
-        <p:nvPicPr>
-          <p:cNvPr id="3" name="Picture 2">
-            <a:extLst>
-              <a:ext uri="{FF2B5EF4-FFF2-40B4-BE49-F238E27FC236}">
-                <a16:creationId xmlns:a16="http://schemas.microsoft.com/office/drawing/2014/main" id="{7D629E7A-873F-C14D-0B20-4F447B950407}"/>
-              </a:ext>
-            </a:extLst>
-          </p:cNvPr>
-          <p:cNvPicPr>
-            <a:picLocks noChangeAspect="1"/>
-          </p:cNvPicPr>
-          <p:nvPr/>
-        </p:nvPicPr>
-        <p:blipFill>
-          <a:blip r:embed="rId2">
-            <a:extLst>
-              <a:ext uri="{28A0092B-C50C-407E-A947-70E740481C1C}">
-                <a14:useLocalDpi xmlns:a14="http://schemas.microsoft.com/office/drawing/2010/main" val="0"/>
-              </a:ext>
-            </a:extLst>
-          </a:blip>
-          <a:stretch>
-            <a:fillRect/>
-          </a:stretch>
-        </p:blipFill>
-        <p:spPr>
-          <a:xfrm>
-            <a:off x="10032437" y="160201"/>
-            <a:ext cx="2035376" cy="516641"/>
-          </a:xfrm>
-          <a:prstGeom prst="rect">
-            <a:avLst/>
-          </a:prstGeom>
-        </p:spPr>
-      </p:pic>
-    </p:spTree>
-    <p:extLst>
-      <p:ext uri="{BB962C8B-B14F-4D97-AF65-F5344CB8AC3E}">
-        <p14:creationId xmlns:p14="http://schemas.microsoft.com/office/powerpoint/2010/main" val="1393089956"/>
-      </p:ext>
-    </p:extLst>
-  </p:cSld>
-  <p:clrMapOvr>
-    <a:masterClrMapping/>
-  </p:clrMapOvr>
-</p:sld>
-</file>
-
-<file path=ppt/slides/slide12.xml><?xml version="1.0" encoding="utf-8"?>
-<p:sld xmlns:a="http://schemas.openxmlformats.org/drawingml/2006/main" xmlns:r="http://schemas.openxmlformats.org/officeDocument/2006/relationships" xmlns:p="http://schemas.openxmlformats.org/presentationml/2006/main">
-  <p:cSld>
-    <p:spTree>
-      <p:nvGrpSpPr>
-        <p:cNvPr id="1" name="">
-          <a:extLst>
-            <a:ext uri="{FF2B5EF4-FFF2-40B4-BE49-F238E27FC236}">
-              <a16:creationId xmlns:a16="http://schemas.microsoft.com/office/drawing/2014/main" id="{3147A995-01EF-3BFB-7823-ADBBEBB2F4D7}"/>
-            </a:ext>
-          </a:extLst>
-        </p:cNvPr>
-        <p:cNvGrpSpPr/>
-        <p:nvPr/>
-      </p:nvGrpSpPr>
-      <p:grpSpPr>
-        <a:xfrm>
-          <a:off x="0" y="0"/>
-          <a:ext cx="0" cy="0"/>
-          <a:chOff x="0" y="0"/>
-          <a:chExt cx="0" cy="0"/>
-        </a:xfrm>
-      </p:grpSpPr>
-      <p:sp>
-        <p:nvSpPr>
-          <p:cNvPr id="109" name="TextShape 1">
-            <a:extLst>
-              <a:ext uri="{FF2B5EF4-FFF2-40B4-BE49-F238E27FC236}">
-                <a16:creationId xmlns:a16="http://schemas.microsoft.com/office/drawing/2014/main" id="{9538C986-A499-4BC7-0FC4-41C7F2F0E21A}"/>
-              </a:ext>
-            </a:extLst>
-          </p:cNvPr>
-          <p:cNvSpPr txBox="1"/>
-          <p:nvPr/>
-        </p:nvSpPr>
-        <p:spPr>
-          <a:xfrm>
-            <a:off x="279555" y="76681"/>
-            <a:ext cx="11053987" cy="979439"/>
-          </a:xfrm>
-          <a:prstGeom prst="rect">
-            <a:avLst/>
-          </a:prstGeom>
-          <a:noFill/>
-          <a:ln>
-            <a:noFill/>
-          </a:ln>
-        </p:spPr>
-        <p:txBody>
-          <a:bodyPr lIns="120000" tIns="60000" rIns="120000" bIns="60000" anchor="ctr">
-            <a:normAutofit fontScale="40000" lnSpcReduction="20000"/>
-          </a:bodyPr>
-          <a:lstStyle/>
-          <a:p>
-            <a:pPr>
-              <a:lnSpc>
-                <a:spcPct val="100000"/>
-              </a:lnSpc>
-            </a:pPr>
-            <a:br>
-              <a:rPr sz="2400" dirty="0"/>
-            </a:br>
-            <a:r>
-              <a:rPr lang="en-US" sz="7866" b="1" spc="-1" dirty="0">
-                <a:solidFill>
-                  <a:srgbClr val="8A0000"/>
-                </a:solidFill>
-                <a:latin typeface="Calibri" panose="020F0502020204030204" pitchFamily="34" charset="0"/>
-                <a:ea typeface="Calibri" panose="020F0502020204030204" pitchFamily="34" charset="0"/>
-                <a:cs typeface="Calibri" panose="020F0502020204030204" pitchFamily="34" charset="0"/>
-              </a:rPr>
-              <a:t>Simulation and Results </a:t>
-            </a:r>
-            <a:br>
-              <a:rPr lang="en-US" sz="7066" b="1" spc="-1" dirty="0">
-                <a:solidFill>
-                  <a:srgbClr val="572314"/>
-                </a:solidFill>
-                <a:latin typeface="Times New Roman" pitchFamily="18" charset="0"/>
-                <a:cs typeface="Times New Roman" pitchFamily="18" charset="0"/>
-              </a:rPr>
-            </a:br>
-            <a:endParaRPr lang="en-US" sz="7066" b="1" spc="-1" dirty="0">
-              <a:solidFill>
-                <a:srgbClr val="572314"/>
-              </a:solidFill>
-              <a:latin typeface="Times New Roman" pitchFamily="18" charset="0"/>
-              <a:cs typeface="Times New Roman" pitchFamily="18" charset="0"/>
-            </a:endParaRPr>
-          </a:p>
-        </p:txBody>
-      </p:sp>
-      <p:sp>
-        <p:nvSpPr>
-          <p:cNvPr id="110" name="TextShape 2">
-            <a:extLst>
-              <a:ext uri="{FF2B5EF4-FFF2-40B4-BE49-F238E27FC236}">
-                <a16:creationId xmlns:a16="http://schemas.microsoft.com/office/drawing/2014/main" id="{B2CA8E46-881A-8416-8683-D5ED614CAA5C}"/>
-              </a:ext>
-            </a:extLst>
-          </p:cNvPr>
-          <p:cNvSpPr txBox="1"/>
-          <p:nvPr/>
-        </p:nvSpPr>
-        <p:spPr>
-          <a:xfrm>
-            <a:off x="305820" y="740701"/>
-            <a:ext cx="11193400" cy="4812680"/>
-          </a:xfrm>
-          <a:prstGeom prst="rect">
-            <a:avLst/>
-          </a:prstGeom>
-          <a:noFill/>
-          <a:ln>
-            <a:noFill/>
-          </a:ln>
-        </p:spPr>
-        <p:txBody>
-          <a:bodyPr lIns="120000" tIns="60000" rIns="120000" bIns="60000">
-            <a:noAutofit/>
-          </a:bodyPr>
-          <a:lstStyle/>
-          <a:p>
-            <a:pPr marL="384710" indent="-457189">
-              <a:spcBef>
-                <a:spcPts val="733"/>
-              </a:spcBef>
-              <a:buClr>
-                <a:srgbClr val="C00000"/>
-              </a:buClr>
-              <a:buFont typeface="Wingdings" panose="05000000000000000000" pitchFamily="2" charset="2"/>
-              <a:buChar char="q"/>
-            </a:pPr>
-            <a:r>
-              <a:rPr lang="en-US" sz="2667" b="1" spc="-1" dirty="0">
-                <a:solidFill>
-                  <a:srgbClr val="000000"/>
-                </a:solidFill>
-                <a:latin typeface="Gill Sans MT"/>
-              </a:rPr>
-              <a:t> </a:t>
-            </a:r>
-            <a:r>
-              <a:rPr lang="en-US" sz="2667" b="1" spc="-1" dirty="0">
-                <a:solidFill>
-                  <a:srgbClr val="000000"/>
-                </a:solidFill>
-                <a:latin typeface="Calibri" panose="020F0502020204030204" pitchFamily="34" charset="0"/>
-                <a:ea typeface="Calibri" panose="020F0502020204030204" pitchFamily="34" charset="0"/>
-                <a:cs typeface="Calibri" panose="020F0502020204030204" pitchFamily="34" charset="0"/>
-              </a:rPr>
-              <a:t>Parameters Descriptions (if any) / Initial Conditions</a:t>
-            </a:r>
-          </a:p>
-          <a:p>
-            <a:endParaRPr lang="en-US" sz="3200" spc="-1" dirty="0">
-              <a:solidFill>
-                <a:srgbClr val="000000"/>
-              </a:solidFill>
-              <a:latin typeface="Calibri" panose="020F0502020204030204" pitchFamily="34" charset="0"/>
-              <a:ea typeface="Calibri" panose="020F0502020204030204" pitchFamily="34" charset="0"/>
-              <a:cs typeface="Calibri" panose="020F0502020204030204" pitchFamily="34" charset="0"/>
-            </a:endParaRPr>
-          </a:p>
-          <a:p>
-            <a:endParaRPr lang="en-US" sz="3200" spc="-1" dirty="0">
-              <a:solidFill>
-                <a:srgbClr val="000000"/>
-              </a:solidFill>
-              <a:latin typeface="Gill Sans MT"/>
-            </a:endParaRPr>
-          </a:p>
-          <a:p>
-            <a:pPr marL="536627">
-              <a:spcBef>
-                <a:spcPts val="733"/>
-              </a:spcBef>
-            </a:pPr>
-            <a:endParaRPr lang="en-US" sz="3200" spc="-1" dirty="0">
-              <a:solidFill>
-                <a:srgbClr val="000000"/>
-              </a:solidFill>
-              <a:latin typeface="Gill Sans MT"/>
-            </a:endParaRPr>
-          </a:p>
-          <a:p>
-            <a:pPr marL="109917">
-              <a:spcBef>
-                <a:spcPts val="801"/>
-              </a:spcBef>
-            </a:pPr>
-            <a:endParaRPr lang="en-US" sz="3200" spc="-1" dirty="0">
-              <a:solidFill>
-                <a:srgbClr val="000000"/>
-              </a:solidFill>
-              <a:latin typeface="Gill Sans MT"/>
-            </a:endParaRPr>
-          </a:p>
-        </p:txBody>
-      </p:sp>
-      <p:sp>
-        <p:nvSpPr>
-          <p:cNvPr id="111" name="TextShape 3">
-            <a:extLst>
-              <a:ext uri="{FF2B5EF4-FFF2-40B4-BE49-F238E27FC236}">
-                <a16:creationId xmlns:a16="http://schemas.microsoft.com/office/drawing/2014/main" id="{8F31D5F8-9576-A840-BF26-6AA4B120CB3B}"/>
-              </a:ext>
-            </a:extLst>
-          </p:cNvPr>
-          <p:cNvSpPr txBox="1"/>
-          <p:nvPr/>
-        </p:nvSpPr>
-        <p:spPr>
-          <a:xfrm>
-            <a:off x="11484960" y="6305400"/>
-            <a:ext cx="609120" cy="475920"/>
-          </a:xfrm>
-          <a:prstGeom prst="rect">
-            <a:avLst/>
-          </a:prstGeom>
-          <a:noFill/>
-          <a:ln>
-            <a:noFill/>
-          </a:ln>
-        </p:spPr>
-        <p:txBody>
-          <a:bodyPr lIns="120000" tIns="60000" rIns="120000" bIns="60000" anchor="b">
-            <a:noAutofit/>
-          </a:bodyPr>
-          <a:lstStyle/>
-          <a:p>
-            <a:pPr algn="ctr">
-              <a:lnSpc>
-                <a:spcPct val="100000"/>
-              </a:lnSpc>
-            </a:pPr>
-            <a:fld id="{528F5C0C-45A4-465E-8315-A9258DDEFD0F}" type="slidenum">
-              <a:rPr lang="en-IN" sz="1600" spc="-1">
-                <a:solidFill>
-                  <a:srgbClr val="B5A989"/>
-                </a:solidFill>
-                <a:latin typeface="Gill Sans MT"/>
-              </a:rPr>
-              <a:pPr algn="ctr">
-                <a:lnSpc>
-                  <a:spcPct val="100000"/>
-                </a:lnSpc>
-              </a:pPr>
-              <a:t>12</a:t>
             </a:fld>
             <a:endParaRPr lang="en-IN" sz="1600" spc="-1">
               <a:latin typeface="Times New Roman"/>
@@ -5971,7 +5413,7 @@
 </p:sld>
 </file>
 
-<file path=ppt/slides/slide13.xml><?xml version="1.0" encoding="utf-8"?>
+<file path=ppt/slides/slide11.xml><?xml version="1.0" encoding="utf-8"?>
 <p:sld xmlns:a="http://schemas.openxmlformats.org/drawingml/2006/main" xmlns:r="http://schemas.openxmlformats.org/officeDocument/2006/relationships" xmlns:p="http://schemas.openxmlformats.org/presentationml/2006/main">
   <p:cSld>
     <p:spTree>
@@ -6224,7 +5666,7 @@
                   <a:spcPct val="100000"/>
                 </a:lnSpc>
               </a:pPr>
-              <a:t>13</a:t>
+              <a:t>11</a:t>
             </a:fld>
             <a:endParaRPr lang="en-IN" sz="1600" spc="-1">
               <a:latin typeface="Times New Roman"/>
@@ -6281,7 +5723,7 @@
 </p:sld>
 </file>
 
-<file path=ppt/slides/slide14.xml><?xml version="1.0" encoding="utf-8"?>
+<file path=ppt/slides/slide12.xml><?xml version="1.0" encoding="utf-8"?>
 <p:sld xmlns:a="http://schemas.openxmlformats.org/drawingml/2006/main" xmlns:r="http://schemas.openxmlformats.org/officeDocument/2006/relationships" xmlns:p="http://schemas.openxmlformats.org/presentationml/2006/main">
   <p:cSld>
     <p:spTree>
@@ -6683,7 +6125,7 @@
                   <a:spcPct val="100000"/>
                 </a:lnSpc>
               </a:pPr>
-              <a:t>14</a:t>
+              <a:t>12</a:t>
             </a:fld>
             <a:endParaRPr lang="en-IN" sz="1600" spc="-1">
               <a:latin typeface="Times New Roman"/>
@@ -6740,7 +6182,7 @@
 </p:sld>
 </file>
 
-<file path=ppt/slides/slide15.xml><?xml version="1.0" encoding="utf-8"?>
+<file path=ppt/slides/slide13.xml><?xml version="1.0" encoding="utf-8"?>
 <p:sld xmlns:a="http://schemas.openxmlformats.org/drawingml/2006/main" xmlns:r="http://schemas.openxmlformats.org/officeDocument/2006/relationships" xmlns:p="http://schemas.openxmlformats.org/presentationml/2006/main">
   <p:cSld>
     <p:spTree>
@@ -6879,7 +6321,7 @@
 </p:sld>
 </file>
 
-<file path=ppt/slides/slide16.xml><?xml version="1.0" encoding="utf-8"?>
+<file path=ppt/slides/slide14.xml><?xml version="1.0" encoding="utf-8"?>
 <p:sld xmlns:a="http://schemas.openxmlformats.org/drawingml/2006/main" xmlns:r="http://schemas.openxmlformats.org/officeDocument/2006/relationships" xmlns:p="http://schemas.openxmlformats.org/presentationml/2006/main">
   <p:cSld>
     <p:spTree>
@@ -6972,7 +6414,7 @@
                   <a:spcPct val="100000"/>
                 </a:lnSpc>
               </a:pPr>
-              <a:t>16</a:t>
+              <a:t>14</a:t>
             </a:fld>
             <a:endParaRPr lang="en-IN" sz="1600" spc="-1">
               <a:latin typeface="Times New Roman"/>
@@ -7635,7 +7077,7 @@
         <p:spPr>
           <a:xfrm>
             <a:off x="239349" y="836712"/>
-            <a:ext cx="11339739" cy="4800240"/>
+            <a:ext cx="11339739" cy="2372832"/>
           </a:xfrm>
           <a:prstGeom prst="rect">
             <a:avLst/>
@@ -7674,6 +7116,50 @@
             </a:r>
           </a:p>
           <a:p>
+            <a:pPr>
+              <a:spcBef>
+                <a:spcPts val="733"/>
+              </a:spcBef>
+              <a:buClr>
+                <a:srgbClr val="C00000"/>
+              </a:buClr>
+            </a:pPr>
+            <a:r>
+              <a:rPr lang="en-US" sz="2667" b="1" spc="-1" dirty="0">
+                <a:solidFill>
+                  <a:srgbClr val="000000"/>
+                </a:solidFill>
+                <a:latin typeface="Calibri" panose="020F0502020204030204" pitchFamily="34" charset="0"/>
+                <a:ea typeface="Calibri" panose="020F0502020204030204" pitchFamily="34" charset="0"/>
+                <a:cs typeface="Calibri" panose="020F0502020204030204" pitchFamily="34" charset="0"/>
+              </a:rPr>
+              <a:t> </a:t>
+            </a:r>
+            <a:r>
+              <a:rPr lang="en-US" sz="2800" dirty="0"/>
+              <a:t>Sentinel IDS is an AI-powered network intrusion detection system that uses a stacking ensemble classifier to identify network anomalies in real-time. The system is built on the UNSW-NB15 benchmark dataset</a:t>
+            </a:r>
+            <a:endParaRPr lang="en-IN" sz="2800" dirty="0"/>
+          </a:p>
+          <a:p>
+            <a:pPr>
+              <a:spcBef>
+                <a:spcPts val="733"/>
+              </a:spcBef>
+              <a:buClr>
+                <a:srgbClr val="C00000"/>
+              </a:buClr>
+            </a:pPr>
+            <a:endParaRPr lang="en-US" sz="2667" b="1" spc="-1" dirty="0">
+              <a:solidFill>
+                <a:srgbClr val="000000"/>
+              </a:solidFill>
+              <a:latin typeface="Calibri" panose="020F0502020204030204" pitchFamily="34" charset="0"/>
+              <a:ea typeface="Calibri" panose="020F0502020204030204" pitchFamily="34" charset="0"/>
+              <a:cs typeface="Calibri" panose="020F0502020204030204" pitchFamily="34" charset="0"/>
+            </a:endParaRPr>
+          </a:p>
+          <a:p>
             <a:pPr marL="384710" indent="-457189">
               <a:spcBef>
                 <a:spcPts val="733"/>
@@ -7684,11 +7170,43 @@
               <a:buFont typeface="Wingdings" panose="05000000000000000000" pitchFamily="2" charset="2"/>
               <a:buChar char="q"/>
             </a:pPr>
-            <a:endParaRPr lang="en-US" sz="2667" b="1" spc="-1" dirty="0">
+            <a:r>
+              <a:rPr lang="en-US" sz="2667" b="1" spc="-1" dirty="0">
+                <a:solidFill>
+                  <a:srgbClr val="000000"/>
+                </a:solidFill>
+                <a:latin typeface="Calibri" panose="020F0502020204030204" pitchFamily="34" charset="0"/>
+                <a:ea typeface="Calibri" panose="020F0502020204030204" pitchFamily="34" charset="0"/>
+                <a:cs typeface="Calibri" panose="020F0502020204030204" pitchFamily="34" charset="0"/>
+              </a:rPr>
+              <a:t>Problem Statement  </a:t>
+            </a:r>
+          </a:p>
+          <a:p>
+            <a:pPr>
+              <a:spcBef>
+                <a:spcPts val="733"/>
+              </a:spcBef>
+              <a:buClr>
+                <a:srgbClr val="C00000"/>
+              </a:buClr>
+            </a:pPr>
+            <a:r>
+              <a:rPr lang="en-US" sz="2800" dirty="0"/>
+              <a:t>Given a stream of network-flow records summarized into a fixed-length feature vector, build an AI-powered system that predicts, for each record, whether it </a:t>
+            </a:r>
+            <a:r>
+              <a:rPr lang="en-US" sz="2670" dirty="0"/>
+              <a:t>represents</a:t>
+            </a:r>
+            <a:r>
+              <a:rPr lang="en-US" sz="2800" dirty="0"/>
+              <a:t> normal traffic or an attack, with a probability that a security analyst can act on.</a:t>
+            </a:r>
+            <a:endParaRPr lang="en-US" sz="2800" spc="-1" dirty="0">
               <a:solidFill>
                 <a:srgbClr val="000000"/>
               </a:solidFill>
-              <a:latin typeface="Calibri" panose="020F0502020204030204" pitchFamily="34" charset="0"/>
               <a:ea typeface="Calibri" panose="020F0502020204030204" pitchFamily="34" charset="0"/>
               <a:cs typeface="Calibri" panose="020F0502020204030204" pitchFamily="34" charset="0"/>
             </a:endParaRPr>
@@ -7784,17 +7302,14 @@
               <a:buFont typeface="Wingdings" panose="05000000000000000000" pitchFamily="2" charset="2"/>
               <a:buChar char="q"/>
             </a:pPr>
-            <a:r>
-              <a:rPr lang="en-US" sz="2667" b="1" spc="-1" dirty="0">
-                <a:solidFill>
-                  <a:srgbClr val="000000"/>
-                </a:solidFill>
-                <a:latin typeface="Calibri" panose="020F0502020204030204" pitchFamily="34" charset="0"/>
-                <a:ea typeface="Calibri" panose="020F0502020204030204" pitchFamily="34" charset="0"/>
-                <a:cs typeface="Calibri" panose="020F0502020204030204" pitchFamily="34" charset="0"/>
-              </a:rPr>
-              <a:t>Problem Statement</a:t>
-            </a:r>
+            <a:endParaRPr lang="en-US" sz="2667" b="1" spc="-1" dirty="0">
+              <a:solidFill>
+                <a:srgbClr val="000000"/>
+              </a:solidFill>
+              <a:latin typeface="Calibri" panose="020F0502020204030204" pitchFamily="34" charset="0"/>
+              <a:ea typeface="Calibri" panose="020F0502020204030204" pitchFamily="34" charset="0"/>
+              <a:cs typeface="Calibri" panose="020F0502020204030204" pitchFamily="34" charset="0"/>
+            </a:endParaRPr>
           </a:p>
           <a:p>
             <a:endParaRPr lang="en-US" sz="3733" b="1" spc="-1" dirty="0">
@@ -8039,7 +7554,7 @@
               <a:buChar char="q"/>
             </a:pPr>
             <a:r>
-              <a:rPr lang="en-US" sz="2667" b="1" spc="-1" dirty="0">
+              <a:rPr lang="en-US" sz="2670" b="1" spc="-1" dirty="0">
                 <a:solidFill>
                   <a:srgbClr val="000000"/>
                 </a:solidFill>
@@ -8051,34 +7566,89 @@
             </a:r>
           </a:p>
           <a:p>
-            <a:endParaRPr lang="en-US" sz="3733" spc="-1" dirty="0">
+            <a:pPr>
+              <a:spcBef>
+                <a:spcPts val="733"/>
+              </a:spcBef>
+              <a:buClr>
+                <a:srgbClr val="C00000"/>
+              </a:buClr>
+            </a:pPr>
+            <a:endParaRPr lang="en-US" sz="2670" b="1" spc="-1" dirty="0">
               <a:solidFill>
                 <a:srgbClr val="000000"/>
               </a:solidFill>
-              <a:latin typeface="Gill Sans MT"/>
+              <a:latin typeface="Calibri" panose="020F0502020204030204" pitchFamily="34" charset="0"/>
+              <a:ea typeface="Calibri" panose="020F0502020204030204" pitchFamily="34" charset="0"/>
+              <a:cs typeface="Calibri" panose="020F0502020204030204" pitchFamily="34" charset="0"/>
             </a:endParaRPr>
           </a:p>
           <a:p>
-            <a:endParaRPr lang="en-US" sz="3733" spc="-1" dirty="0">
-              <a:solidFill>
-                <a:srgbClr val="000000"/>
-              </a:solidFill>
-              <a:latin typeface="Gill Sans MT"/>
-            </a:endParaRPr>
-          </a:p>
-          <a:p>
-            <a:endParaRPr lang="en-US" sz="3733" spc="-1" dirty="0">
-              <a:solidFill>
-                <a:srgbClr val="000000"/>
-              </a:solidFill>
-              <a:latin typeface="Gill Sans MT"/>
-            </a:endParaRPr>
-          </a:p>
-          <a:p>
-            <a:pPr marL="536627">
+            <a:r>
+              <a:rPr lang="en-US" sz="2670" b="1" dirty="0"/>
+              <a:t>Operational</a:t>
+            </a:r>
+            <a:r>
+              <a:rPr lang="en-US" sz="2670" dirty="0"/>
+              <a:t>: Security Operations </a:t>
+            </a:r>
+            <a:r>
+              <a:rPr lang="en-US" sz="2670" dirty="0" err="1"/>
+              <a:t>Centres</a:t>
+            </a:r>
+            <a:r>
+              <a:rPr lang="en-US" sz="2670" dirty="0"/>
+              <a:t> (SOCs) are understaffed and overwhelmed by false alerts. A machine-learning Network Intrusion Detection System (NIDS) that produces </a:t>
+            </a:r>
+            <a:r>
+              <a:rPr lang="en-US" sz="2670" b="1" dirty="0"/>
+              <a:t>calibrated probability scores</a:t>
+            </a:r>
+            <a:r>
+              <a:rPr lang="en-US" sz="2670" dirty="0"/>
+              <a:t> allows analysts to set conservative alert thresholds, significantly reducing false positives without missing critical attacks.</a:t>
+            </a:r>
+          </a:p>
+          <a:p>
+            <a:endParaRPr lang="en-US" sz="2670" dirty="0"/>
+          </a:p>
+          <a:p>
+            <a:endParaRPr lang="en-US" sz="2670" dirty="0"/>
+          </a:p>
+          <a:p>
+            <a:r>
+              <a:rPr lang="en-US" sz="2670" b="1" dirty="0"/>
+              <a:t>Research</a:t>
+            </a:r>
+            <a:r>
+              <a:rPr lang="en-US" sz="2670" dirty="0"/>
+              <a:t>: Network benchmarks (specifically the </a:t>
+            </a:r>
+            <a:r>
+              <a:rPr lang="en-US" sz="2670" b="1" dirty="0"/>
+              <a:t>UNSW-NB15</a:t>
+            </a:r>
+            <a:r>
+              <a:rPr lang="en-US" sz="2670" dirty="0"/>
+              <a:t> dataset used here) serve as standard baselines for evaluating classifier robustness, feature engineering, and the benefits of </a:t>
+            </a:r>
+            <a:r>
+              <a:rPr lang="en-US" sz="2670" dirty="0" err="1"/>
+              <a:t>ensembling</a:t>
+            </a:r>
+            <a:r>
+              <a:rPr lang="en-US" sz="2670" dirty="0"/>
+              <a:t>.</a:t>
+            </a:r>
+          </a:p>
+          <a:p>
+            <a:pPr>
               <a:spcBef>
                 <a:spcPts val="733"/>
               </a:spcBef>
+              <a:buClr>
+                <a:srgbClr val="C00000"/>
+              </a:buClr>
             </a:pPr>
             <a:endParaRPr lang="en-US" sz="3733" spc="-1" dirty="0">
               <a:solidFill>
@@ -8329,6 +7899,128 @@
             </a:r>
           </a:p>
           <a:p>
+            <a:pPr>
+              <a:spcBef>
+                <a:spcPts val="733"/>
+              </a:spcBef>
+              <a:buClr>
+                <a:srgbClr val="C00000"/>
+              </a:buClr>
+            </a:pPr>
+            <a:endParaRPr lang="en-US" sz="2667" b="1" spc="-1" dirty="0">
+              <a:solidFill>
+                <a:srgbClr val="000000"/>
+              </a:solidFill>
+              <a:latin typeface="Calibri" panose="020F0502020204030204" pitchFamily="34" charset="0"/>
+              <a:ea typeface="Calibri" panose="020F0502020204030204" pitchFamily="34" charset="0"/>
+              <a:cs typeface="Calibri" panose="020F0502020204030204" pitchFamily="34" charset="0"/>
+            </a:endParaRPr>
+          </a:p>
+          <a:p>
+            <a:r>
+              <a:rPr lang="en-US" sz="2000" b="1" dirty="0"/>
+              <a:t>Signature-Based Detection</a:t>
+            </a:r>
+          </a:p>
+          <a:p>
+            <a:r>
+              <a:rPr lang="en-US" sz="2000" b="1" dirty="0"/>
+              <a:t>Key Tools</a:t>
+            </a:r>
+            <a:r>
+              <a:rPr lang="en-US" sz="2000" dirty="0"/>
+              <a:t>: </a:t>
+            </a:r>
+            <a:r>
+              <a:rPr lang="en-US" sz="2000" b="1" dirty="0"/>
+              <a:t>Snort</a:t>
+            </a:r>
+            <a:r>
+              <a:rPr lang="en-US" sz="2000" dirty="0"/>
+              <a:t> (Martin Roesch, 1998) and </a:t>
+            </a:r>
+            <a:r>
+              <a:rPr lang="en-US" sz="2000" b="1" dirty="0"/>
+              <a:t>Suricata</a:t>
+            </a:r>
+            <a:r>
+              <a:rPr lang="en-US" sz="2000" dirty="0"/>
+              <a:t> (OISF, 2010).</a:t>
+            </a:r>
+          </a:p>
+          <a:p>
+            <a:r>
+              <a:rPr lang="en-US" sz="2000" b="1" dirty="0"/>
+              <a:t>Mechanism</a:t>
+            </a:r>
+            <a:r>
+              <a:rPr lang="en-US" sz="2000" dirty="0"/>
+              <a:t>: Matches incoming network packets against a database of curated rule patterns (signatures).</a:t>
+            </a:r>
+          </a:p>
+          <a:p>
+            <a:r>
+              <a:rPr lang="en-US" sz="2000" b="1" dirty="0"/>
+              <a:t>Strengths</a:t>
+            </a:r>
+            <a:r>
+              <a:rPr lang="en-US" sz="2000" dirty="0"/>
+              <a:t>:</a:t>
+            </a:r>
+          </a:p>
+          <a:p>
+            <a:pPr lvl="1"/>
+            <a:r>
+              <a:rPr lang="en-US" sz="2000" dirty="0"/>
+              <a:t>Exceptionally fast matching for known attack variants.</a:t>
+            </a:r>
+          </a:p>
+          <a:p>
+            <a:pPr lvl="1"/>
+            <a:r>
+              <a:rPr lang="en-US" sz="2000" dirty="0"/>
+              <a:t>Low computational complexity under normal rule counts.</a:t>
+            </a:r>
+          </a:p>
+          <a:p>
+            <a:pPr lvl="1"/>
+            <a:r>
+              <a:rPr lang="en-US" sz="2000" dirty="0"/>
+              <a:t>Near-zero false-positive rates on covered traffic.</a:t>
+            </a:r>
+          </a:p>
+          <a:p>
+            <a:r>
+              <a:rPr lang="en-US" sz="2000" b="1" dirty="0"/>
+              <a:t>Weaknesses</a:t>
+            </a:r>
+            <a:r>
+              <a:rPr lang="en-US" sz="2000" dirty="0"/>
+              <a:t>:</a:t>
+            </a:r>
+          </a:p>
+          <a:p>
+            <a:pPr lvl="1"/>
+            <a:r>
+              <a:rPr lang="en-US" sz="2000" dirty="0"/>
+              <a:t>Completely blind to zero-day attacks.</a:t>
+            </a:r>
+          </a:p>
+          <a:p>
+            <a:pPr lvl="1"/>
+            <a:r>
+              <a:rPr lang="en-US" sz="2000" dirty="0"/>
+              <a:t>Easily bypassed by minor mutations in attack payloads.</a:t>
+            </a:r>
+          </a:p>
+          <a:p>
+            <a:pPr lvl="1"/>
+            <a:r>
+              <a:rPr lang="en-US" sz="2000" dirty="0"/>
+              <a:t>High operational maintenance cost (continuous manual curation of signatures).</a:t>
+            </a:r>
+          </a:p>
+          <a:p>
             <a:endParaRPr lang="en-US" sz="2667" b="1" spc="-1" dirty="0">
               <a:solidFill>
                 <a:srgbClr val="000000"/>
@@ -8474,7 +8166,7 @@
         <p:cNvPr id="1" name="">
           <a:extLst>
             <a:ext uri="{FF2B5EF4-FFF2-40B4-BE49-F238E27FC236}">
-              <a16:creationId xmlns:a16="http://schemas.microsoft.com/office/drawing/2014/main" id="{6D167AF1-BE59-6F47-8D82-74577F14AF39}"/>
+              <a16:creationId xmlns:a16="http://schemas.microsoft.com/office/drawing/2014/main" id="{D99DE7D6-03BF-ABD4-5963-0B5933A50A01}"/>
             </a:ext>
           </a:extLst>
         </p:cNvPr>
@@ -8494,7 +8186,7 @@
           <p:cNvPr id="109" name="TextShape 1">
             <a:extLst>
               <a:ext uri="{FF2B5EF4-FFF2-40B4-BE49-F238E27FC236}">
-                <a16:creationId xmlns:a16="http://schemas.microsoft.com/office/drawing/2014/main" id="{87099D82-27AF-790A-F4C4-8CDA517EDB6D}"/>
+                <a16:creationId xmlns:a16="http://schemas.microsoft.com/office/drawing/2014/main" id="{2E241FF9-5D2F-1BC3-DBC2-17F24C9AB970}"/>
               </a:ext>
             </a:extLst>
           </p:cNvPr>
@@ -8503,7 +8195,7 @@
         </p:nvSpPr>
         <p:spPr>
           <a:xfrm>
-            <a:off x="102860" y="68627"/>
+            <a:off x="250476" y="265392"/>
             <a:ext cx="11053987" cy="1142640"/>
           </a:xfrm>
           <a:prstGeom prst="rect">
@@ -8537,7 +8229,7 @@
                 <a:ea typeface="Calibri" panose="020F0502020204030204" pitchFamily="34" charset="0"/>
                 <a:cs typeface="Calibri" panose="020F0502020204030204" pitchFamily="34" charset="0"/>
               </a:rPr>
-              <a:t>Background &amp; Related Work / Literature Review</a:t>
+              <a:t>Project Objectives</a:t>
             </a:r>
             <a:br>
               <a:rPr lang="en-US" sz="7066" b="1" spc="-1" dirty="0">
@@ -8563,7 +8255,7 @@
           <p:cNvPr id="110" name="TextShape 2">
             <a:extLst>
               <a:ext uri="{FF2B5EF4-FFF2-40B4-BE49-F238E27FC236}">
-                <a16:creationId xmlns:a16="http://schemas.microsoft.com/office/drawing/2014/main" id="{A09CD804-8FB9-C4C6-6D5A-14FF502429C5}"/>
+                <a16:creationId xmlns:a16="http://schemas.microsoft.com/office/drawing/2014/main" id="{715BEA23-F073-686E-2A38-52DB7FE8849D}"/>
               </a:ext>
             </a:extLst>
           </p:cNvPr>
@@ -8573,7 +8265,7 @@
         <p:spPr>
           <a:xfrm>
             <a:off x="269283" y="836712"/>
-            <a:ext cx="11193400" cy="4812680"/>
+            <a:ext cx="11193400" cy="4969728"/>
           </a:xfrm>
           <a:prstGeom prst="rect">
             <a:avLst/>
@@ -8589,18 +8281,13 @@
           </a:bodyPr>
           <a:lstStyle/>
           <a:p>
-            <a:pPr marL="384710" indent="-457189">
-              <a:spcBef>
-                <a:spcPts val="733"/>
-              </a:spcBef>
+            <a:pPr>
               <a:buClr>
                 <a:srgbClr val="C00000"/>
               </a:buClr>
-              <a:buFont typeface="Wingdings" panose="05000000000000000000" pitchFamily="2" charset="2"/>
-              <a:buChar char="q"/>
-            </a:pPr>
-            <a:r>
-              <a:rPr lang="en-US" sz="2667" b="1" spc="-1" dirty="0">
+            </a:pPr>
+            <a:r>
+              <a:rPr lang="en-US" sz="2667" spc="-1" dirty="0">
                 <a:solidFill>
                   <a:srgbClr val="000000"/>
                 </a:solidFill>
@@ -8608,27 +8295,246 @@
                 <a:ea typeface="Calibri" panose="020F0502020204030204" pitchFamily="34" charset="0"/>
                 <a:cs typeface="Calibri" panose="020F0502020204030204" pitchFamily="34" charset="0"/>
               </a:rPr>
-              <a:t>Gaps Identified / Improvements over Existing Solutions</a:t>
-            </a:r>
-          </a:p>
-          <a:p>
-            <a:pPr marL="457189" indent="-457189">
-              <a:buFont typeface="Wingdings" panose="05000000000000000000" pitchFamily="2" charset="2"/>
-              <a:buChar char="q"/>
-            </a:pPr>
-            <a:endParaRPr lang="en-US" sz="3200" spc="-1" dirty="0">
+              <a:t> </a:t>
+            </a:r>
+          </a:p>
+          <a:p>
+            <a:pPr>
+              <a:buClr>
+                <a:srgbClr val="C00000"/>
+              </a:buClr>
+            </a:pPr>
+            <a:r>
+              <a:rPr lang="en-US" b="1" dirty="0"/>
+              <a:t>Binary Classification</a:t>
+            </a:r>
+            <a:r>
+              <a:rPr lang="en-US" dirty="0"/>
+              <a:t>: Classify each network flow as </a:t>
+            </a:r>
+            <a:r>
+              <a:rPr lang="en-US" b="1" dirty="0"/>
+              <a:t>Normal</a:t>
+            </a:r>
+            <a:r>
+              <a:rPr lang="en-US" dirty="0"/>
+              <a:t> or </a:t>
+            </a:r>
+            <a:r>
+              <a:rPr lang="en-US" b="1" dirty="0"/>
+              <a:t>Attack</a:t>
+            </a:r>
+            <a:r>
+              <a:rPr lang="en-US" dirty="0"/>
+              <a:t> using a binary classification pipeline with a customizable decision threshold.</a:t>
+            </a:r>
+            <a:endParaRPr lang="en-US" sz="2667" spc="-1" dirty="0">
               <a:solidFill>
                 <a:srgbClr val="000000"/>
               </a:solidFill>
-              <a:latin typeface="Gill Sans MT"/>
+              <a:latin typeface="Calibri" panose="020F0502020204030204" pitchFamily="34" charset="0"/>
+              <a:ea typeface="Calibri" panose="020F0502020204030204" pitchFamily="34" charset="0"/>
+              <a:cs typeface="Calibri" panose="020F0502020204030204" pitchFamily="34" charset="0"/>
             </a:endParaRPr>
           </a:p>
           <a:p>
-            <a:endParaRPr lang="en-US" sz="3200" spc="-1" dirty="0">
+            <a:pPr>
+              <a:buClr>
+                <a:srgbClr val="C00000"/>
+              </a:buClr>
+            </a:pPr>
+            <a:endParaRPr lang="en-US" sz="2667" spc="-1" dirty="0">
               <a:solidFill>
                 <a:srgbClr val="000000"/>
               </a:solidFill>
-              <a:latin typeface="Gill Sans MT"/>
+              <a:latin typeface="Calibri" panose="020F0502020204030204" pitchFamily="34" charset="0"/>
+              <a:ea typeface="Calibri" panose="020F0502020204030204" pitchFamily="34" charset="0"/>
+              <a:cs typeface="Calibri" panose="020F0502020204030204" pitchFamily="34" charset="0"/>
+            </a:endParaRPr>
+          </a:p>
+          <a:p>
+            <a:pPr>
+              <a:buClr>
+                <a:srgbClr val="C00000"/>
+              </a:buClr>
+            </a:pPr>
+            <a:r>
+              <a:rPr lang="en-US" b="1" dirty="0"/>
+              <a:t>Stacking Ensemble</a:t>
+            </a:r>
+            <a:r>
+              <a:rPr lang="en-US" dirty="0"/>
+              <a:t>: Combine 5 heterogeneous base classifiers (</a:t>
+            </a:r>
+            <a:r>
+              <a:rPr lang="en-US" b="1" dirty="0"/>
+              <a:t>Random Forest</a:t>
+            </a:r>
+            <a:r>
+              <a:rPr lang="en-US" dirty="0"/>
+              <a:t>, </a:t>
+            </a:r>
+            <a:r>
+              <a:rPr lang="en-US" b="1" dirty="0" err="1"/>
+              <a:t>XGBoost</a:t>
+            </a:r>
+            <a:r>
+              <a:rPr lang="en-US" dirty="0"/>
+              <a:t>, </a:t>
+            </a:r>
+            <a:r>
+              <a:rPr lang="en-US" b="1" dirty="0" err="1"/>
+              <a:t>LightGBM</a:t>
+            </a:r>
+            <a:r>
+              <a:rPr lang="en-US" dirty="0"/>
+              <a:t>, </a:t>
+            </a:r>
+            <a:r>
+              <a:rPr lang="en-US" b="1" dirty="0"/>
+              <a:t>Extra Trees</a:t>
+            </a:r>
+            <a:r>
+              <a:rPr lang="en-US" dirty="0"/>
+              <a:t>, and </a:t>
+            </a:r>
+            <a:r>
+              <a:rPr lang="en-US" b="1" dirty="0"/>
+              <a:t>MLP Neural Network</a:t>
+            </a:r>
+            <a:r>
+              <a:rPr lang="en-US" dirty="0"/>
+              <a:t>) via a Level-2 meta-learner (</a:t>
+            </a:r>
+            <a:r>
+              <a:rPr lang="en-US" b="1" dirty="0"/>
+              <a:t>Logistic Regression</a:t>
+            </a:r>
+            <a:r>
+              <a:rPr lang="en-US" dirty="0"/>
+              <a:t>) to achieve higher accuracy than any single model.</a:t>
+            </a:r>
+          </a:p>
+          <a:p>
+            <a:pPr>
+              <a:buClr>
+                <a:srgbClr val="C00000"/>
+              </a:buClr>
+            </a:pPr>
+            <a:endParaRPr lang="en-US" sz="2667" spc="-1" dirty="0">
+              <a:solidFill>
+                <a:srgbClr val="000000"/>
+              </a:solidFill>
+              <a:latin typeface="Calibri" panose="020F0502020204030204" pitchFamily="34" charset="0"/>
+              <a:ea typeface="Calibri" panose="020F0502020204030204" pitchFamily="34" charset="0"/>
+              <a:cs typeface="Calibri" panose="020F0502020204030204" pitchFamily="34" charset="0"/>
+            </a:endParaRPr>
+          </a:p>
+          <a:p>
+            <a:pPr>
+              <a:buClr>
+                <a:srgbClr val="C00000"/>
+              </a:buClr>
+            </a:pPr>
+            <a:r>
+              <a:rPr lang="en-US" b="1" dirty="0"/>
+              <a:t>Probability Calibration</a:t>
+            </a:r>
+            <a:r>
+              <a:rPr lang="en-US" dirty="0"/>
+              <a:t>: Apply probability calibration (evaluating Platt scaling, isotonic regression, and temperature scaling) to align predicted probabilities with actual attack likelihoods.</a:t>
+            </a:r>
+          </a:p>
+          <a:p>
+            <a:pPr>
+              <a:buClr>
+                <a:srgbClr val="C00000"/>
+              </a:buClr>
+            </a:pPr>
+            <a:endParaRPr lang="en-US" dirty="0"/>
+          </a:p>
+          <a:p>
+            <a:pPr>
+              <a:buClr>
+                <a:srgbClr val="C00000"/>
+              </a:buClr>
+            </a:pPr>
+            <a:r>
+              <a:rPr lang="en-US" b="1" dirty="0"/>
+              <a:t>Interactive Console &amp; API</a:t>
+            </a:r>
+            <a:r>
+              <a:rPr lang="en-US" dirty="0"/>
+              <a:t>: Provide a Flask REST API for single and batch predictions, and a React web dashboard for real-time monitoring and threat level visualization.</a:t>
+            </a:r>
+          </a:p>
+          <a:p>
+            <a:pPr>
+              <a:buClr>
+                <a:srgbClr val="C00000"/>
+              </a:buClr>
+            </a:pPr>
+            <a:endParaRPr lang="en-US" dirty="0"/>
+          </a:p>
+          <a:p>
+            <a:pPr>
+              <a:buClr>
+                <a:srgbClr val="C00000"/>
+              </a:buClr>
+            </a:pPr>
+            <a:r>
+              <a:rPr lang="en-US" b="1" dirty="0"/>
+              <a:t>False Alarm Mitigation</a:t>
+            </a:r>
+            <a:r>
+              <a:rPr lang="en-US" dirty="0"/>
+              <a:t>: Enable security operators to explore trade-offs between recall and false-positive rates to adjust thresholds to their workload.</a:t>
+            </a:r>
+          </a:p>
+          <a:p>
+            <a:pPr>
+              <a:buClr>
+                <a:srgbClr val="C00000"/>
+              </a:buClr>
+            </a:pPr>
+            <a:endParaRPr lang="en-US" dirty="0"/>
+          </a:p>
+          <a:p>
+            <a:pPr>
+              <a:buClr>
+                <a:srgbClr val="C00000"/>
+              </a:buClr>
+            </a:pPr>
+            <a:endParaRPr lang="en-US" dirty="0"/>
+          </a:p>
+          <a:p>
+            <a:pPr>
+              <a:buClr>
+                <a:srgbClr val="C00000"/>
+              </a:buClr>
+            </a:pPr>
+            <a:endParaRPr lang="en-US" sz="2667" spc="-1" dirty="0">
+              <a:solidFill>
+                <a:srgbClr val="000000"/>
+              </a:solidFill>
+              <a:latin typeface="Calibri" panose="020F0502020204030204" pitchFamily="34" charset="0"/>
+              <a:ea typeface="Calibri" panose="020F0502020204030204" pitchFamily="34" charset="0"/>
+              <a:cs typeface="Calibri" panose="020F0502020204030204" pitchFamily="34" charset="0"/>
+            </a:endParaRPr>
+          </a:p>
+          <a:p>
+            <a:pPr>
+              <a:buClr>
+                <a:srgbClr val="C00000"/>
+              </a:buClr>
+            </a:pPr>
+            <a:endParaRPr lang="en-US" sz="2667" spc="-1" dirty="0">
+              <a:solidFill>
+                <a:srgbClr val="000000"/>
+              </a:solidFill>
+              <a:latin typeface="Calibri" panose="020F0502020204030204" pitchFamily="34" charset="0"/>
+              <a:ea typeface="Calibri" panose="020F0502020204030204" pitchFamily="34" charset="0"/>
+              <a:cs typeface="Calibri" panose="020F0502020204030204" pitchFamily="34" charset="0"/>
             </a:endParaRPr>
           </a:p>
           <a:p>
@@ -8637,11 +8543,13 @@
                 <a:spcPts val="733"/>
               </a:spcBef>
             </a:pPr>
-            <a:endParaRPr lang="en-US" sz="3200" spc="-1" dirty="0">
+            <a:endParaRPr lang="en-US" sz="2667" spc="-1" dirty="0">
               <a:solidFill>
                 <a:srgbClr val="000000"/>
               </a:solidFill>
-              <a:latin typeface="Gill Sans MT"/>
+              <a:latin typeface="Calibri" panose="020F0502020204030204" pitchFamily="34" charset="0"/>
+              <a:ea typeface="Calibri" panose="020F0502020204030204" pitchFamily="34" charset="0"/>
+              <a:cs typeface="Calibri" panose="020F0502020204030204" pitchFamily="34" charset="0"/>
             </a:endParaRPr>
           </a:p>
           <a:p>
@@ -8650,11 +8558,13 @@
                 <a:spcPts val="801"/>
               </a:spcBef>
             </a:pPr>
-            <a:endParaRPr lang="en-US" sz="3200" spc="-1" dirty="0">
+            <a:endParaRPr lang="en-US" sz="2667" spc="-1" dirty="0">
               <a:solidFill>
                 <a:srgbClr val="000000"/>
               </a:solidFill>
-              <a:latin typeface="Gill Sans MT"/>
+              <a:latin typeface="Calibri" panose="020F0502020204030204" pitchFamily="34" charset="0"/>
+              <a:ea typeface="Calibri" panose="020F0502020204030204" pitchFamily="34" charset="0"/>
+              <a:cs typeface="Calibri" panose="020F0502020204030204" pitchFamily="34" charset="0"/>
             </a:endParaRPr>
           </a:p>
         </p:txBody>
@@ -8664,7 +8574,7 @@
           <p:cNvPr id="111" name="TextShape 3">
             <a:extLst>
               <a:ext uri="{FF2B5EF4-FFF2-40B4-BE49-F238E27FC236}">
-                <a16:creationId xmlns:a16="http://schemas.microsoft.com/office/drawing/2014/main" id="{8D6AF4AD-9CAB-8255-1B67-55C19C994E41}"/>
+                <a16:creationId xmlns:a16="http://schemas.microsoft.com/office/drawing/2014/main" id="{C3F1BA4A-B791-6659-F2FD-2647DE6FC648}"/>
               </a:ext>
             </a:extLst>
           </p:cNvPr>
@@ -8708,406 +8618,6 @@
                 </a:lnSpc>
               </a:pPr>
               <a:t>6</a:t>
-            </a:fld>
-            <a:endParaRPr lang="en-IN" sz="1600" spc="-1">
-              <a:latin typeface="Times New Roman"/>
-            </a:endParaRPr>
-          </a:p>
-        </p:txBody>
-      </p:sp>
-      <p:pic>
-        <p:nvPicPr>
-          <p:cNvPr id="3" name="Picture 2">
-            <a:extLst>
-              <a:ext uri="{FF2B5EF4-FFF2-40B4-BE49-F238E27FC236}">
-                <a16:creationId xmlns:a16="http://schemas.microsoft.com/office/drawing/2014/main" id="{49D9BC8F-3683-6FA3-721D-8F2B9E45C1B1}"/>
-              </a:ext>
-            </a:extLst>
-          </p:cNvPr>
-          <p:cNvPicPr>
-            <a:picLocks noChangeAspect="1"/>
-          </p:cNvPicPr>
-          <p:nvPr/>
-        </p:nvPicPr>
-        <p:blipFill>
-          <a:blip r:embed="rId2">
-            <a:extLst>
-              <a:ext uri="{28A0092B-C50C-407E-A947-70E740481C1C}">
-                <a14:useLocalDpi xmlns:a14="http://schemas.microsoft.com/office/drawing/2010/main" val="0"/>
-              </a:ext>
-            </a:extLst>
-          </a:blip>
-          <a:stretch>
-            <a:fillRect/>
-          </a:stretch>
-        </p:blipFill>
-        <p:spPr>
-          <a:xfrm>
-            <a:off x="10032437" y="160201"/>
-            <a:ext cx="2035376" cy="516641"/>
-          </a:xfrm>
-          <a:prstGeom prst="rect">
-            <a:avLst/>
-          </a:prstGeom>
-        </p:spPr>
-      </p:pic>
-    </p:spTree>
-    <p:extLst>
-      <p:ext uri="{BB962C8B-B14F-4D97-AF65-F5344CB8AC3E}">
-        <p14:creationId xmlns:p14="http://schemas.microsoft.com/office/powerpoint/2010/main" val="900071537"/>
-      </p:ext>
-    </p:extLst>
-  </p:cSld>
-  <p:clrMapOvr>
-    <a:masterClrMapping/>
-  </p:clrMapOvr>
-</p:sld>
-</file>
-
-<file path=ppt/slides/slide7.xml><?xml version="1.0" encoding="utf-8"?>
-<p:sld xmlns:a="http://schemas.openxmlformats.org/drawingml/2006/main" xmlns:r="http://schemas.openxmlformats.org/officeDocument/2006/relationships" xmlns:p="http://schemas.openxmlformats.org/presentationml/2006/main">
-  <p:cSld>
-    <p:spTree>
-      <p:nvGrpSpPr>
-        <p:cNvPr id="1" name="">
-          <a:extLst>
-            <a:ext uri="{FF2B5EF4-FFF2-40B4-BE49-F238E27FC236}">
-              <a16:creationId xmlns:a16="http://schemas.microsoft.com/office/drawing/2014/main" id="{D99DE7D6-03BF-ABD4-5963-0B5933A50A01}"/>
-            </a:ext>
-          </a:extLst>
-        </p:cNvPr>
-        <p:cNvGrpSpPr/>
-        <p:nvPr/>
-      </p:nvGrpSpPr>
-      <p:grpSpPr>
-        <a:xfrm>
-          <a:off x="0" y="0"/>
-          <a:ext cx="0" cy="0"/>
-          <a:chOff x="0" y="0"/>
-          <a:chExt cx="0" cy="0"/>
-        </a:xfrm>
-      </p:grpSpPr>
-      <p:sp>
-        <p:nvSpPr>
-          <p:cNvPr id="109" name="TextShape 1">
-            <a:extLst>
-              <a:ext uri="{FF2B5EF4-FFF2-40B4-BE49-F238E27FC236}">
-                <a16:creationId xmlns:a16="http://schemas.microsoft.com/office/drawing/2014/main" id="{2E241FF9-5D2F-1BC3-DBC2-17F24C9AB970}"/>
-              </a:ext>
-            </a:extLst>
-          </p:cNvPr>
-          <p:cNvSpPr txBox="1"/>
-          <p:nvPr/>
-        </p:nvSpPr>
-        <p:spPr>
-          <a:xfrm>
-            <a:off x="250476" y="265392"/>
-            <a:ext cx="11053987" cy="1142640"/>
-          </a:xfrm>
-          <a:prstGeom prst="rect">
-            <a:avLst/>
-          </a:prstGeom>
-          <a:noFill/>
-          <a:ln>
-            <a:noFill/>
-          </a:ln>
-        </p:spPr>
-        <p:txBody>
-          <a:bodyPr lIns="120000" tIns="60000" rIns="120000" bIns="60000" anchor="ctr">
-            <a:normAutofit fontScale="47500" lnSpcReduction="20000"/>
-          </a:bodyPr>
-          <a:lstStyle/>
-          <a:p>
-            <a:pPr>
-              <a:lnSpc>
-                <a:spcPct val="100000"/>
-              </a:lnSpc>
-            </a:pPr>
-            <a:br>
-              <a:rPr sz="2400" dirty="0"/>
-            </a:br>
-            <a:r>
-              <a:rPr lang="en-US" sz="6800" b="1" spc="-1" dirty="0">
-                <a:solidFill>
-                  <a:srgbClr val="8A0000"/>
-                </a:solidFill>
-                <a:latin typeface="Calibri" panose="020F0502020204030204" pitchFamily="34" charset="0"/>
-                <a:ea typeface="Calibri" panose="020F0502020204030204" pitchFamily="34" charset="0"/>
-                <a:cs typeface="Calibri" panose="020F0502020204030204" pitchFamily="34" charset="0"/>
-              </a:rPr>
-              <a:t>Project Objectives</a:t>
-            </a:r>
-            <a:br>
-              <a:rPr lang="en-US" sz="7066" b="1" spc="-1" dirty="0">
-                <a:solidFill>
-                  <a:srgbClr val="572314"/>
-                </a:solidFill>
-                <a:latin typeface="Times New Roman" pitchFamily="18" charset="0"/>
-                <a:cs typeface="Times New Roman" pitchFamily="18" charset="0"/>
-              </a:rPr>
-            </a:br>
-            <a:endParaRPr lang="en-US" sz="7066" b="1" spc="-1" dirty="0">
-              <a:solidFill>
-                <a:srgbClr val="572314"/>
-              </a:solidFill>
-              <a:latin typeface="Times New Roman" pitchFamily="18" charset="0"/>
-              <a:cs typeface="Times New Roman" pitchFamily="18" charset="0"/>
-            </a:endParaRPr>
-          </a:p>
-        </p:txBody>
-      </p:sp>
-      <p:sp>
-        <p:nvSpPr>
-          <p:cNvPr id="110" name="TextShape 2">
-            <a:extLst>
-              <a:ext uri="{FF2B5EF4-FFF2-40B4-BE49-F238E27FC236}">
-                <a16:creationId xmlns:a16="http://schemas.microsoft.com/office/drawing/2014/main" id="{715BEA23-F073-686E-2A38-52DB7FE8849D}"/>
-              </a:ext>
-            </a:extLst>
-          </p:cNvPr>
-          <p:cNvSpPr txBox="1"/>
-          <p:nvPr/>
-        </p:nvSpPr>
-        <p:spPr>
-          <a:xfrm>
-            <a:off x="269283" y="836712"/>
-            <a:ext cx="11193400" cy="4812680"/>
-          </a:xfrm>
-          <a:prstGeom prst="rect">
-            <a:avLst/>
-          </a:prstGeom>
-          <a:noFill/>
-          <a:ln>
-            <a:noFill/>
-          </a:ln>
-        </p:spPr>
-        <p:txBody>
-          <a:bodyPr lIns="120000" tIns="60000" rIns="120000" bIns="60000">
-            <a:noAutofit/>
-          </a:bodyPr>
-          <a:lstStyle/>
-          <a:p>
-            <a:endParaRPr lang="en-US" sz="2667" spc="-1" dirty="0">
-              <a:solidFill>
-                <a:srgbClr val="000000"/>
-              </a:solidFill>
-              <a:latin typeface="Calibri" panose="020F0502020204030204" pitchFamily="34" charset="0"/>
-              <a:ea typeface="Calibri" panose="020F0502020204030204" pitchFamily="34" charset="0"/>
-              <a:cs typeface="Calibri" panose="020F0502020204030204" pitchFamily="34" charset="0"/>
-            </a:endParaRPr>
-          </a:p>
-          <a:p>
-            <a:pPr marL="609585" indent="-609585">
-              <a:buClr>
-                <a:srgbClr val="C00000"/>
-              </a:buClr>
-              <a:buFont typeface="+mj-lt"/>
-              <a:buAutoNum type="arabicPeriod"/>
-            </a:pPr>
-            <a:r>
-              <a:rPr lang="en-US" sz="2667" spc="-1" dirty="0">
-                <a:solidFill>
-                  <a:srgbClr val="000000"/>
-                </a:solidFill>
-                <a:latin typeface="Calibri" panose="020F0502020204030204" pitchFamily="34" charset="0"/>
-                <a:ea typeface="Calibri" panose="020F0502020204030204" pitchFamily="34" charset="0"/>
-                <a:cs typeface="Calibri" panose="020F0502020204030204" pitchFamily="34" charset="0"/>
-              </a:rPr>
-              <a:t> </a:t>
-            </a:r>
-          </a:p>
-          <a:p>
-            <a:pPr marL="609585" indent="-609585">
-              <a:buClr>
-                <a:srgbClr val="C00000"/>
-              </a:buClr>
-              <a:buFont typeface="+mj-lt"/>
-              <a:buAutoNum type="arabicPeriod"/>
-            </a:pPr>
-            <a:endParaRPr lang="en-US" sz="2667" spc="-1" dirty="0">
-              <a:solidFill>
-                <a:srgbClr val="000000"/>
-              </a:solidFill>
-              <a:latin typeface="Calibri" panose="020F0502020204030204" pitchFamily="34" charset="0"/>
-              <a:ea typeface="Calibri" panose="020F0502020204030204" pitchFamily="34" charset="0"/>
-              <a:cs typeface="Calibri" panose="020F0502020204030204" pitchFamily="34" charset="0"/>
-            </a:endParaRPr>
-          </a:p>
-          <a:p>
-            <a:pPr marL="609585" indent="-609585">
-              <a:buClr>
-                <a:srgbClr val="C00000"/>
-              </a:buClr>
-              <a:buFont typeface="+mj-lt"/>
-              <a:buAutoNum type="arabicPeriod"/>
-            </a:pPr>
-            <a:r>
-              <a:rPr lang="en-US" sz="2667" spc="-1" dirty="0">
-                <a:solidFill>
-                  <a:srgbClr val="000000"/>
-                </a:solidFill>
-                <a:latin typeface="Calibri" panose="020F0502020204030204" pitchFamily="34" charset="0"/>
-                <a:ea typeface="Calibri" panose="020F0502020204030204" pitchFamily="34" charset="0"/>
-                <a:cs typeface="Calibri" panose="020F0502020204030204" pitchFamily="34" charset="0"/>
-              </a:rPr>
-              <a:t> </a:t>
-            </a:r>
-          </a:p>
-          <a:p>
-            <a:pPr marL="609585" indent="-609585">
-              <a:buClr>
-                <a:srgbClr val="C00000"/>
-              </a:buClr>
-              <a:buFont typeface="+mj-lt"/>
-              <a:buAutoNum type="arabicPeriod"/>
-            </a:pPr>
-            <a:endParaRPr lang="en-US" sz="2667" spc="-1" dirty="0">
-              <a:solidFill>
-                <a:srgbClr val="000000"/>
-              </a:solidFill>
-              <a:latin typeface="Calibri" panose="020F0502020204030204" pitchFamily="34" charset="0"/>
-              <a:ea typeface="Calibri" panose="020F0502020204030204" pitchFamily="34" charset="0"/>
-              <a:cs typeface="Calibri" panose="020F0502020204030204" pitchFamily="34" charset="0"/>
-            </a:endParaRPr>
-          </a:p>
-          <a:p>
-            <a:pPr marL="609585" indent="-609585">
-              <a:buClr>
-                <a:srgbClr val="C00000"/>
-              </a:buClr>
-              <a:buFont typeface="+mj-lt"/>
-              <a:buAutoNum type="arabicPeriod"/>
-            </a:pPr>
-            <a:r>
-              <a:rPr lang="en-US" sz="2667" spc="-1" dirty="0">
-                <a:solidFill>
-                  <a:srgbClr val="000000"/>
-                </a:solidFill>
-                <a:latin typeface="Calibri" panose="020F0502020204030204" pitchFamily="34" charset="0"/>
-                <a:ea typeface="Calibri" panose="020F0502020204030204" pitchFamily="34" charset="0"/>
-                <a:cs typeface="Calibri" panose="020F0502020204030204" pitchFamily="34" charset="0"/>
-              </a:rPr>
-              <a:t> </a:t>
-            </a:r>
-          </a:p>
-          <a:p>
-            <a:pPr marL="609585" indent="-609585">
-              <a:buClr>
-                <a:srgbClr val="C00000"/>
-              </a:buClr>
-              <a:buFont typeface="+mj-lt"/>
-              <a:buAutoNum type="arabicPeriod"/>
-            </a:pPr>
-            <a:endParaRPr lang="en-US" sz="2667" spc="-1" dirty="0">
-              <a:solidFill>
-                <a:srgbClr val="000000"/>
-              </a:solidFill>
-              <a:latin typeface="Calibri" panose="020F0502020204030204" pitchFamily="34" charset="0"/>
-              <a:ea typeface="Calibri" panose="020F0502020204030204" pitchFamily="34" charset="0"/>
-              <a:cs typeface="Calibri" panose="020F0502020204030204" pitchFamily="34" charset="0"/>
-            </a:endParaRPr>
-          </a:p>
-          <a:p>
-            <a:pPr marL="609585" indent="-609585">
-              <a:buClr>
-                <a:srgbClr val="C00000"/>
-              </a:buClr>
-              <a:buFont typeface="+mj-lt"/>
-              <a:buAutoNum type="arabicPeriod"/>
-            </a:pPr>
-            <a:r>
-              <a:rPr lang="en-US" sz="2667" spc="-1" dirty="0">
-                <a:solidFill>
-                  <a:srgbClr val="000000"/>
-                </a:solidFill>
-                <a:latin typeface="Calibri" panose="020F0502020204030204" pitchFamily="34" charset="0"/>
-                <a:ea typeface="Calibri" panose="020F0502020204030204" pitchFamily="34" charset="0"/>
-                <a:cs typeface="Calibri" panose="020F0502020204030204" pitchFamily="34" charset="0"/>
-              </a:rPr>
-              <a:t> </a:t>
-            </a:r>
-          </a:p>
-          <a:p>
-            <a:pPr marL="536627">
-              <a:spcBef>
-                <a:spcPts val="733"/>
-              </a:spcBef>
-            </a:pPr>
-            <a:endParaRPr lang="en-US" sz="2667" spc="-1" dirty="0">
-              <a:solidFill>
-                <a:srgbClr val="000000"/>
-              </a:solidFill>
-              <a:latin typeface="Calibri" panose="020F0502020204030204" pitchFamily="34" charset="0"/>
-              <a:ea typeface="Calibri" panose="020F0502020204030204" pitchFamily="34" charset="0"/>
-              <a:cs typeface="Calibri" panose="020F0502020204030204" pitchFamily="34" charset="0"/>
-            </a:endParaRPr>
-          </a:p>
-          <a:p>
-            <a:pPr marL="109917">
-              <a:spcBef>
-                <a:spcPts val="801"/>
-              </a:spcBef>
-            </a:pPr>
-            <a:endParaRPr lang="en-US" sz="2667" spc="-1" dirty="0">
-              <a:solidFill>
-                <a:srgbClr val="000000"/>
-              </a:solidFill>
-              <a:latin typeface="Calibri" panose="020F0502020204030204" pitchFamily="34" charset="0"/>
-              <a:ea typeface="Calibri" panose="020F0502020204030204" pitchFamily="34" charset="0"/>
-              <a:cs typeface="Calibri" panose="020F0502020204030204" pitchFamily="34" charset="0"/>
-            </a:endParaRPr>
-          </a:p>
-        </p:txBody>
-      </p:sp>
-      <p:sp>
-        <p:nvSpPr>
-          <p:cNvPr id="111" name="TextShape 3">
-            <a:extLst>
-              <a:ext uri="{FF2B5EF4-FFF2-40B4-BE49-F238E27FC236}">
-                <a16:creationId xmlns:a16="http://schemas.microsoft.com/office/drawing/2014/main" id="{C3F1BA4A-B791-6659-F2FD-2647DE6FC648}"/>
-              </a:ext>
-            </a:extLst>
-          </p:cNvPr>
-          <p:cNvSpPr txBox="1"/>
-          <p:nvPr/>
-        </p:nvSpPr>
-        <p:spPr>
-          <a:xfrm>
-            <a:off x="11484960" y="6305400"/>
-            <a:ext cx="609120" cy="475920"/>
-          </a:xfrm>
-          <a:prstGeom prst="rect">
-            <a:avLst/>
-          </a:prstGeom>
-          <a:noFill/>
-          <a:ln>
-            <a:noFill/>
-          </a:ln>
-        </p:spPr>
-        <p:txBody>
-          <a:bodyPr lIns="120000" tIns="60000" rIns="120000" bIns="60000" anchor="b">
-            <a:noAutofit/>
-          </a:bodyPr>
-          <a:lstStyle/>
-          <a:p>
-            <a:pPr algn="ctr">
-              <a:lnSpc>
-                <a:spcPct val="100000"/>
-              </a:lnSpc>
-            </a:pPr>
-            <a:fld id="{528F5C0C-45A4-465E-8315-A9258DDEFD0F}" type="slidenum">
-              <a:rPr lang="en-IN" sz="1600" spc="-1">
-                <a:solidFill>
-                  <a:srgbClr val="B5A989"/>
-                </a:solidFill>
-                <a:latin typeface="Gill Sans MT"/>
-              </a:rPr>
-              <a:pPr algn="ctr">
-                <a:lnSpc>
-                  <a:spcPct val="100000"/>
-                </a:lnSpc>
-              </a:pPr>
-              <a:t>7</a:t>
             </a:fld>
             <a:endParaRPr lang="en-IN" sz="1600" spc="-1">
               <a:latin typeface="Times New Roman"/>
@@ -9164,307 +8674,7 @@
 </p:sld>
 </file>
 
-<file path=ppt/slides/slide8.xml><?xml version="1.0" encoding="utf-8"?>
-<p:sld xmlns:a="http://schemas.openxmlformats.org/drawingml/2006/main" xmlns:r="http://schemas.openxmlformats.org/officeDocument/2006/relationships" xmlns:p="http://schemas.openxmlformats.org/presentationml/2006/main">
-  <p:cSld>
-    <p:spTree>
-      <p:nvGrpSpPr>
-        <p:cNvPr id="1" name="">
-          <a:extLst>
-            <a:ext uri="{FF2B5EF4-FFF2-40B4-BE49-F238E27FC236}">
-              <a16:creationId xmlns:a16="http://schemas.microsoft.com/office/drawing/2014/main" id="{27377216-89C0-CB9D-AE24-E3E9229B8B21}"/>
-            </a:ext>
-          </a:extLst>
-        </p:cNvPr>
-        <p:cNvGrpSpPr/>
-        <p:nvPr/>
-      </p:nvGrpSpPr>
-      <p:grpSpPr>
-        <a:xfrm>
-          <a:off x="0" y="0"/>
-          <a:ext cx="0" cy="0"/>
-          <a:chOff x="0" y="0"/>
-          <a:chExt cx="0" cy="0"/>
-        </a:xfrm>
-      </p:grpSpPr>
-      <p:sp>
-        <p:nvSpPr>
-          <p:cNvPr id="109" name="TextShape 1">
-            <a:extLst>
-              <a:ext uri="{FF2B5EF4-FFF2-40B4-BE49-F238E27FC236}">
-                <a16:creationId xmlns:a16="http://schemas.microsoft.com/office/drawing/2014/main" id="{C2B8452B-B807-C124-7AEC-AE5ED6AE1FBE}"/>
-              </a:ext>
-            </a:extLst>
-          </p:cNvPr>
-          <p:cNvSpPr txBox="1"/>
-          <p:nvPr/>
-        </p:nvSpPr>
-        <p:spPr>
-          <a:xfrm>
-            <a:off x="279555" y="76681"/>
-            <a:ext cx="11053987" cy="979439"/>
-          </a:xfrm>
-          <a:prstGeom prst="rect">
-            <a:avLst/>
-          </a:prstGeom>
-          <a:noFill/>
-          <a:ln>
-            <a:noFill/>
-          </a:ln>
-        </p:spPr>
-        <p:txBody>
-          <a:bodyPr lIns="120000" tIns="60000" rIns="120000" bIns="60000" anchor="ctr">
-            <a:normAutofit fontScale="40000" lnSpcReduction="20000"/>
-          </a:bodyPr>
-          <a:lstStyle/>
-          <a:p>
-            <a:pPr>
-              <a:lnSpc>
-                <a:spcPct val="100000"/>
-              </a:lnSpc>
-            </a:pPr>
-            <a:br>
-              <a:rPr sz="2400" dirty="0"/>
-            </a:br>
-            <a:r>
-              <a:rPr lang="en-US" sz="7866" b="1" spc="-1" dirty="0">
-                <a:solidFill>
-                  <a:srgbClr val="8A0000"/>
-                </a:solidFill>
-                <a:latin typeface="Calibri" panose="020F0502020204030204" pitchFamily="34" charset="0"/>
-                <a:ea typeface="Calibri" panose="020F0502020204030204" pitchFamily="34" charset="0"/>
-                <a:cs typeface="Calibri" panose="020F0502020204030204" pitchFamily="34" charset="0"/>
-              </a:rPr>
-              <a:t>Proposed Solution</a:t>
-            </a:r>
-            <a:br>
-              <a:rPr lang="en-US" sz="7066" b="1" spc="-1" dirty="0">
-                <a:solidFill>
-                  <a:srgbClr val="572314"/>
-                </a:solidFill>
-                <a:latin typeface="Times New Roman" pitchFamily="18" charset="0"/>
-                <a:cs typeface="Times New Roman" pitchFamily="18" charset="0"/>
-              </a:rPr>
-            </a:br>
-            <a:endParaRPr lang="en-US" sz="7066" b="1" spc="-1" dirty="0">
-              <a:solidFill>
-                <a:srgbClr val="572314"/>
-              </a:solidFill>
-              <a:latin typeface="Times New Roman" pitchFamily="18" charset="0"/>
-              <a:cs typeface="Times New Roman" pitchFamily="18" charset="0"/>
-            </a:endParaRPr>
-          </a:p>
-        </p:txBody>
-      </p:sp>
-      <p:sp>
-        <p:nvSpPr>
-          <p:cNvPr id="110" name="TextShape 2">
-            <a:extLst>
-              <a:ext uri="{FF2B5EF4-FFF2-40B4-BE49-F238E27FC236}">
-                <a16:creationId xmlns:a16="http://schemas.microsoft.com/office/drawing/2014/main" id="{C5E87E07-06AC-81A7-D8B2-979F958A9CDA}"/>
-              </a:ext>
-            </a:extLst>
-          </p:cNvPr>
-          <p:cNvSpPr txBox="1"/>
-          <p:nvPr/>
-        </p:nvSpPr>
-        <p:spPr>
-          <a:xfrm>
-            <a:off x="279555" y="740701"/>
-            <a:ext cx="11193400" cy="4812680"/>
-          </a:xfrm>
-          <a:prstGeom prst="rect">
-            <a:avLst/>
-          </a:prstGeom>
-          <a:noFill/>
-          <a:ln>
-            <a:noFill/>
-          </a:ln>
-        </p:spPr>
-        <p:txBody>
-          <a:bodyPr lIns="120000" tIns="60000" rIns="120000" bIns="60000">
-            <a:noAutofit/>
-          </a:bodyPr>
-          <a:lstStyle/>
-          <a:p>
-            <a:pPr marL="384710" indent="-457189">
-              <a:spcBef>
-                <a:spcPts val="733"/>
-              </a:spcBef>
-              <a:buClr>
-                <a:srgbClr val="C00000"/>
-              </a:buClr>
-              <a:buFont typeface="Wingdings" panose="05000000000000000000" pitchFamily="2" charset="2"/>
-              <a:buChar char="q"/>
-            </a:pPr>
-            <a:r>
-              <a:rPr lang="en-US" sz="2667" b="1" spc="-1" dirty="0">
-                <a:solidFill>
-                  <a:srgbClr val="000000"/>
-                </a:solidFill>
-                <a:latin typeface="Calibri" panose="020F0502020204030204" pitchFamily="34" charset="0"/>
-                <a:ea typeface="Calibri" panose="020F0502020204030204" pitchFamily="34" charset="0"/>
-                <a:cs typeface="Calibri" panose="020F0502020204030204" pitchFamily="34" charset="0"/>
-              </a:rPr>
-              <a:t>System Architecture / Model Diagram / Workflow / UML diagrams</a:t>
-            </a:r>
-          </a:p>
-          <a:p>
-            <a:pPr marL="457189" indent="-457189">
-              <a:buFont typeface="Arial" panose="020B0604020202020204" pitchFamily="34" charset="0"/>
-              <a:buChar char="•"/>
-            </a:pPr>
-            <a:endParaRPr lang="en-US" sz="3200" spc="-1" dirty="0">
-              <a:solidFill>
-                <a:srgbClr val="000000"/>
-              </a:solidFill>
-              <a:latin typeface="Calibri" panose="020F0502020204030204" pitchFamily="34" charset="0"/>
-              <a:ea typeface="Calibri" panose="020F0502020204030204" pitchFamily="34" charset="0"/>
-              <a:cs typeface="Calibri" panose="020F0502020204030204" pitchFamily="34" charset="0"/>
-            </a:endParaRPr>
-          </a:p>
-          <a:p>
-            <a:endParaRPr lang="en-US" sz="3200" spc="-1" dirty="0">
-              <a:solidFill>
-                <a:srgbClr val="000000"/>
-              </a:solidFill>
-              <a:latin typeface="Gill Sans MT"/>
-            </a:endParaRPr>
-          </a:p>
-          <a:p>
-            <a:pPr marL="536627">
-              <a:spcBef>
-                <a:spcPts val="733"/>
-              </a:spcBef>
-            </a:pPr>
-            <a:endParaRPr lang="en-US" sz="3200" spc="-1" dirty="0">
-              <a:solidFill>
-                <a:srgbClr val="000000"/>
-              </a:solidFill>
-              <a:latin typeface="Gill Sans MT"/>
-            </a:endParaRPr>
-          </a:p>
-          <a:p>
-            <a:pPr marL="109917">
-              <a:spcBef>
-                <a:spcPts val="801"/>
-              </a:spcBef>
-            </a:pPr>
-            <a:endParaRPr lang="en-US" sz="3200" spc="-1" dirty="0">
-              <a:solidFill>
-                <a:srgbClr val="000000"/>
-              </a:solidFill>
-              <a:latin typeface="Gill Sans MT"/>
-            </a:endParaRPr>
-          </a:p>
-        </p:txBody>
-      </p:sp>
-      <p:sp>
-        <p:nvSpPr>
-          <p:cNvPr id="111" name="TextShape 3">
-            <a:extLst>
-              <a:ext uri="{FF2B5EF4-FFF2-40B4-BE49-F238E27FC236}">
-                <a16:creationId xmlns:a16="http://schemas.microsoft.com/office/drawing/2014/main" id="{76ABF230-9CC5-BA19-052D-F9AD7EDF257F}"/>
-              </a:ext>
-            </a:extLst>
-          </p:cNvPr>
-          <p:cNvSpPr txBox="1"/>
-          <p:nvPr/>
-        </p:nvSpPr>
-        <p:spPr>
-          <a:xfrm>
-            <a:off x="11484960" y="6305400"/>
-            <a:ext cx="609120" cy="475920"/>
-          </a:xfrm>
-          <a:prstGeom prst="rect">
-            <a:avLst/>
-          </a:prstGeom>
-          <a:noFill/>
-          <a:ln>
-            <a:noFill/>
-          </a:ln>
-        </p:spPr>
-        <p:txBody>
-          <a:bodyPr lIns="120000" tIns="60000" rIns="120000" bIns="60000" anchor="b">
-            <a:noAutofit/>
-          </a:bodyPr>
-          <a:lstStyle/>
-          <a:p>
-            <a:pPr algn="ctr">
-              <a:lnSpc>
-                <a:spcPct val="100000"/>
-              </a:lnSpc>
-            </a:pPr>
-            <a:fld id="{528F5C0C-45A4-465E-8315-A9258DDEFD0F}" type="slidenum">
-              <a:rPr lang="en-IN" sz="1600" spc="-1">
-                <a:solidFill>
-                  <a:srgbClr val="B5A989"/>
-                </a:solidFill>
-                <a:latin typeface="Gill Sans MT"/>
-              </a:rPr>
-              <a:pPr algn="ctr">
-                <a:lnSpc>
-                  <a:spcPct val="100000"/>
-                </a:lnSpc>
-              </a:pPr>
-              <a:t>8</a:t>
-            </a:fld>
-            <a:endParaRPr lang="en-IN" sz="1600" spc="-1">
-              <a:latin typeface="Times New Roman"/>
-            </a:endParaRPr>
-          </a:p>
-        </p:txBody>
-      </p:sp>
-      <p:pic>
-        <p:nvPicPr>
-          <p:cNvPr id="3" name="Picture 2">
-            <a:extLst>
-              <a:ext uri="{FF2B5EF4-FFF2-40B4-BE49-F238E27FC236}">
-                <a16:creationId xmlns:a16="http://schemas.microsoft.com/office/drawing/2014/main" id="{253CA4B3-7F11-0967-B261-8D75F14384EF}"/>
-              </a:ext>
-            </a:extLst>
-          </p:cNvPr>
-          <p:cNvPicPr>
-            <a:picLocks noChangeAspect="1"/>
-          </p:cNvPicPr>
-          <p:nvPr/>
-        </p:nvPicPr>
-        <p:blipFill>
-          <a:blip r:embed="rId2">
-            <a:extLst>
-              <a:ext uri="{28A0092B-C50C-407E-A947-70E740481C1C}">
-                <a14:useLocalDpi xmlns:a14="http://schemas.microsoft.com/office/drawing/2010/main" val="0"/>
-              </a:ext>
-            </a:extLst>
-          </a:blip>
-          <a:stretch>
-            <a:fillRect/>
-          </a:stretch>
-        </p:blipFill>
-        <p:spPr>
-          <a:xfrm>
-            <a:off x="10032437" y="160201"/>
-            <a:ext cx="2035376" cy="516641"/>
-          </a:xfrm>
-          <a:prstGeom prst="rect">
-            <a:avLst/>
-          </a:prstGeom>
-        </p:spPr>
-      </p:pic>
-    </p:spTree>
-    <p:extLst>
-      <p:ext uri="{BB962C8B-B14F-4D97-AF65-F5344CB8AC3E}">
-        <p14:creationId xmlns:p14="http://schemas.microsoft.com/office/powerpoint/2010/main" val="2534295434"/>
-      </p:ext>
-    </p:extLst>
-  </p:cSld>
-  <p:clrMapOvr>
-    <a:masterClrMapping/>
-  </p:clrMapOvr>
-</p:sld>
-</file>
-
-<file path=ppt/slides/slide9.xml><?xml version="1.0" encoding="utf-8"?>
+<file path=ppt/slides/slide7.xml><?xml version="1.0" encoding="utf-8"?>
 <p:sld xmlns:a="http://schemas.openxmlformats.org/drawingml/2006/main" xmlns:r="http://schemas.openxmlformats.org/officeDocument/2006/relationships" xmlns:p="http://schemas.openxmlformats.org/presentationml/2006/main">
   <p:cSld>
     <p:spTree>
@@ -9610,6 +8820,116 @@
             </a:r>
           </a:p>
           <a:p>
+            <a:pPr>
+              <a:spcBef>
+                <a:spcPts val="733"/>
+              </a:spcBef>
+              <a:buClr>
+                <a:srgbClr val="C00000"/>
+              </a:buClr>
+            </a:pPr>
+            <a:endParaRPr lang="en-US" sz="2667" b="1" spc="-1" dirty="0">
+              <a:solidFill>
+                <a:srgbClr val="000000"/>
+              </a:solidFill>
+              <a:latin typeface="Calibri" panose="020F0502020204030204" pitchFamily="34" charset="0"/>
+              <a:ea typeface="Calibri" panose="020F0502020204030204" pitchFamily="34" charset="0"/>
+              <a:cs typeface="Calibri" panose="020F0502020204030204" pitchFamily="34" charset="0"/>
+            </a:endParaRPr>
+          </a:p>
+          <a:p>
+            <a:r>
+              <a:rPr lang="en-US" sz="2400" b="1" dirty="0"/>
+              <a:t>Core System Features</a:t>
+            </a:r>
+          </a:p>
+          <a:p>
+            <a:r>
+              <a:rPr lang="en-US" b="1" dirty="0"/>
+              <a:t>Real-time Prediction</a:t>
+            </a:r>
+            <a:r>
+              <a:rPr lang="en-US" dirty="0"/>
+              <a:t>: Analysts can submit individual flow records via a custom-designed form or as raw space-delimited text vectors.</a:t>
+            </a:r>
+          </a:p>
+          <a:p>
+            <a:r>
+              <a:rPr lang="en-US" b="1" dirty="0"/>
+              <a:t>Calibrated Threat Classification</a:t>
+            </a:r>
+            <a:r>
+              <a:rPr lang="en-US" dirty="0"/>
+              <a:t>: Translates calibrated probabilities into color-coded threat level badges:</a:t>
+            </a:r>
+          </a:p>
+          <a:p>
+            <a:pPr lvl="1"/>
+            <a:r>
+              <a:rPr lang="en-US" b="1" dirty="0"/>
+              <a:t>LOW</a:t>
+            </a:r>
+            <a:r>
+              <a:rPr lang="en-US" dirty="0"/>
+              <a:t> (probability &lt; 40%): Green badge.</a:t>
+            </a:r>
+          </a:p>
+          <a:p>
+            <a:pPr lvl="1"/>
+            <a:r>
+              <a:rPr lang="en-US" b="1" dirty="0"/>
+              <a:t>MEDIUM</a:t>
+            </a:r>
+            <a:r>
+              <a:rPr lang="en-US" dirty="0"/>
+              <a:t> (40% - 70%): Amber badge.</a:t>
+            </a:r>
+          </a:p>
+          <a:p>
+            <a:pPr lvl="1"/>
+            <a:r>
+              <a:rPr lang="en-US" b="1" dirty="0"/>
+              <a:t>HIGH</a:t>
+            </a:r>
+            <a:r>
+              <a:rPr lang="en-US" dirty="0"/>
+              <a:t> (probability &gt; 70%): Red badge.</a:t>
+            </a:r>
+          </a:p>
+          <a:p>
+            <a:r>
+              <a:rPr lang="en-US" b="1" dirty="0"/>
+              <a:t>Simulated Batch Stream</a:t>
+            </a:r>
+            <a:r>
+              <a:rPr lang="en-US" dirty="0"/>
+              <a:t>: Simulates batch flows (up to 200 records at once) with live chart updates graphing intrusion percentage ratios.</a:t>
+            </a:r>
+          </a:p>
+          <a:p>
+            <a:r>
+              <a:rPr lang="en-US" b="1" dirty="0"/>
+              <a:t>Security Auditing</a:t>
+            </a:r>
+            <a:r>
+              <a:rPr lang="en-US" dirty="0"/>
+              <a:t>: A persistent, scrollable prediction history panel allowing operators to examine audit logs of recent traffic runs.</a:t>
+            </a:r>
+          </a:p>
+          <a:p>
+            <a:r>
+              <a:rPr lang="en-US" b="1" dirty="0"/>
+              <a:t>Automatic Offline Verification</a:t>
+            </a:r>
+            <a:r>
+              <a:rPr lang="en-US" dirty="0"/>
+              <a:t>: The project includes smoke and integration test suites ([test_backend_connection.py]) verifying model metadata, routing, and schema structures.</a:t>
+            </a:r>
+          </a:p>
+          <a:p>
+            <a:endParaRPr lang="en-US" sz="2400" b="1" dirty="0"/>
+          </a:p>
+          <a:p>
             <a:endParaRPr lang="en-US" sz="3200" spc="-1" dirty="0">
               <a:solidFill>
                 <a:srgbClr val="000000"/>
@@ -9703,7 +9023,7 @@
                   <a:spcPct val="100000"/>
                 </a:lnSpc>
               </a:pPr>
-              <a:t>9</a:t>
+              <a:t>7</a:t>
             </a:fld>
             <a:endParaRPr lang="en-IN" sz="1600" spc="-1">
               <a:latin typeface="Times New Roman"/>
@@ -9751,6 +9071,832 @@
     <p:extLst>
       <p:ext uri="{BB962C8B-B14F-4D97-AF65-F5344CB8AC3E}">
         <p14:creationId xmlns:p14="http://schemas.microsoft.com/office/powerpoint/2010/main" val="323131930"/>
+      </p:ext>
+    </p:extLst>
+  </p:cSld>
+  <p:clrMapOvr>
+    <a:masterClrMapping/>
+  </p:clrMapOvr>
+</p:sld>
+</file>
+
+<file path=ppt/slides/slide8.xml><?xml version="1.0" encoding="utf-8"?>
+<p:sld xmlns:a="http://schemas.openxmlformats.org/drawingml/2006/main" xmlns:r="http://schemas.openxmlformats.org/officeDocument/2006/relationships" xmlns:p="http://schemas.openxmlformats.org/presentationml/2006/main">
+  <p:cSld>
+    <p:spTree>
+      <p:nvGrpSpPr>
+        <p:cNvPr id="1" name="">
+          <a:extLst>
+            <a:ext uri="{FF2B5EF4-FFF2-40B4-BE49-F238E27FC236}">
+              <a16:creationId xmlns:a16="http://schemas.microsoft.com/office/drawing/2014/main" id="{1430AD02-BE5E-1467-2150-90B5D7403CC8}"/>
+            </a:ext>
+          </a:extLst>
+        </p:cNvPr>
+        <p:cNvGrpSpPr/>
+        <p:nvPr/>
+      </p:nvGrpSpPr>
+      <p:grpSpPr>
+        <a:xfrm>
+          <a:off x="0" y="0"/>
+          <a:ext cx="0" cy="0"/>
+          <a:chOff x="0" y="0"/>
+          <a:chExt cx="0" cy="0"/>
+        </a:xfrm>
+      </p:grpSpPr>
+      <p:sp>
+        <p:nvSpPr>
+          <p:cNvPr id="109" name="TextShape 1">
+            <a:extLst>
+              <a:ext uri="{FF2B5EF4-FFF2-40B4-BE49-F238E27FC236}">
+                <a16:creationId xmlns:a16="http://schemas.microsoft.com/office/drawing/2014/main" id="{AFE7C81F-6E58-2367-107E-6694BBFC4019}"/>
+              </a:ext>
+            </a:extLst>
+          </p:cNvPr>
+          <p:cNvSpPr txBox="1"/>
+          <p:nvPr/>
+        </p:nvSpPr>
+        <p:spPr>
+          <a:xfrm>
+            <a:off x="279555" y="76681"/>
+            <a:ext cx="11053987" cy="979439"/>
+          </a:xfrm>
+          <a:prstGeom prst="rect">
+            <a:avLst/>
+          </a:prstGeom>
+          <a:noFill/>
+          <a:ln>
+            <a:noFill/>
+          </a:ln>
+        </p:spPr>
+        <p:txBody>
+          <a:bodyPr lIns="120000" tIns="60000" rIns="120000" bIns="60000" anchor="ctr">
+            <a:normAutofit fontScale="40000" lnSpcReduction="20000"/>
+          </a:bodyPr>
+          <a:lstStyle/>
+          <a:p>
+            <a:pPr>
+              <a:lnSpc>
+                <a:spcPct val="100000"/>
+              </a:lnSpc>
+            </a:pPr>
+            <a:br>
+              <a:rPr sz="2400" dirty="0"/>
+            </a:br>
+            <a:r>
+              <a:rPr lang="en-US" sz="7866" b="1" spc="-1" dirty="0">
+                <a:solidFill>
+                  <a:srgbClr val="8A0000"/>
+                </a:solidFill>
+                <a:latin typeface="Calibri" panose="020F0502020204030204" pitchFamily="34" charset="0"/>
+                <a:ea typeface="Calibri" panose="020F0502020204030204" pitchFamily="34" charset="0"/>
+                <a:cs typeface="Calibri" panose="020F0502020204030204" pitchFamily="34" charset="0"/>
+              </a:rPr>
+              <a:t>Proposed Solution</a:t>
+            </a:r>
+            <a:br>
+              <a:rPr lang="en-US" sz="7066" b="1" spc="-1" dirty="0">
+                <a:solidFill>
+                  <a:srgbClr val="572314"/>
+                </a:solidFill>
+                <a:latin typeface="Times New Roman" pitchFamily="18" charset="0"/>
+                <a:cs typeface="Times New Roman" pitchFamily="18" charset="0"/>
+              </a:rPr>
+            </a:br>
+            <a:endParaRPr lang="en-US" sz="7066" b="1" spc="-1" dirty="0">
+              <a:solidFill>
+                <a:srgbClr val="572314"/>
+              </a:solidFill>
+              <a:latin typeface="Times New Roman" pitchFamily="18" charset="0"/>
+              <a:cs typeface="Times New Roman" pitchFamily="18" charset="0"/>
+            </a:endParaRPr>
+          </a:p>
+        </p:txBody>
+      </p:sp>
+      <p:sp>
+        <p:nvSpPr>
+          <p:cNvPr id="110" name="TextShape 2">
+            <a:extLst>
+              <a:ext uri="{FF2B5EF4-FFF2-40B4-BE49-F238E27FC236}">
+                <a16:creationId xmlns:a16="http://schemas.microsoft.com/office/drawing/2014/main" id="{9C105956-1DE0-D7E6-B955-48A1A17A560C}"/>
+              </a:ext>
+            </a:extLst>
+          </p:cNvPr>
+          <p:cNvSpPr txBox="1"/>
+          <p:nvPr/>
+        </p:nvSpPr>
+        <p:spPr>
+          <a:xfrm>
+            <a:off x="291560" y="740701"/>
+            <a:ext cx="11193400" cy="516641"/>
+          </a:xfrm>
+          <a:prstGeom prst="rect">
+            <a:avLst/>
+          </a:prstGeom>
+          <a:noFill/>
+          <a:ln>
+            <a:noFill/>
+          </a:ln>
+        </p:spPr>
+        <p:txBody>
+          <a:bodyPr lIns="120000" tIns="60000" rIns="120000" bIns="60000">
+            <a:noAutofit/>
+          </a:bodyPr>
+          <a:lstStyle/>
+          <a:p>
+            <a:pPr marL="384710" indent="-457189">
+              <a:spcBef>
+                <a:spcPts val="733"/>
+              </a:spcBef>
+              <a:buClr>
+                <a:srgbClr val="C00000"/>
+              </a:buClr>
+              <a:buFont typeface="Wingdings" panose="05000000000000000000" pitchFamily="2" charset="2"/>
+              <a:buChar char="q"/>
+            </a:pPr>
+            <a:r>
+              <a:rPr lang="en-US" sz="2667" b="1" spc="-1" dirty="0">
+                <a:solidFill>
+                  <a:srgbClr val="000000"/>
+                </a:solidFill>
+                <a:latin typeface="Calibri" panose="020F0502020204030204" pitchFamily="34" charset="0"/>
+                <a:ea typeface="Calibri" panose="020F0502020204030204" pitchFamily="34" charset="0"/>
+                <a:cs typeface="Calibri" panose="020F0502020204030204" pitchFamily="34" charset="0"/>
+              </a:rPr>
+              <a:t>Algorithms / Technologies, Frameworks, and Tools Used</a:t>
+            </a:r>
+          </a:p>
+          <a:p>
+            <a:endParaRPr lang="en-US" sz="3200" spc="-1" dirty="0">
+              <a:solidFill>
+                <a:srgbClr val="000000"/>
+              </a:solidFill>
+              <a:latin typeface="Gill Sans MT"/>
+            </a:endParaRPr>
+          </a:p>
+          <a:p>
+            <a:r>
+              <a:rPr lang="en-US" sz="2400" b="1" dirty="0"/>
+              <a:t>Machine Learning Algorithms</a:t>
+            </a:r>
+          </a:p>
+          <a:p>
+            <a:r>
+              <a:rPr lang="en-US" dirty="0"/>
+              <a:t>The project utilizes a </a:t>
+            </a:r>
+            <a:r>
+              <a:rPr lang="en-US" b="1" dirty="0"/>
+              <a:t>hybrid stacking ensemble</a:t>
+            </a:r>
+            <a:r>
+              <a:rPr lang="en-US" dirty="0"/>
+              <a:t> (Level-1 base learners combined via a Level-2 meta-learner) consisting of the following algorithms:</a:t>
+            </a:r>
+          </a:p>
+          <a:p>
+            <a:r>
+              <a:rPr lang="en-US" b="1" dirty="0"/>
+              <a:t>Random Forest (RF),</a:t>
+            </a:r>
+            <a:r>
+              <a:rPr lang="en-US" dirty="0"/>
+              <a:t> </a:t>
+            </a:r>
+            <a:r>
+              <a:rPr lang="en-US" b="1" dirty="0"/>
+              <a:t>Extra Trees (ET),</a:t>
+            </a:r>
+            <a:r>
+              <a:rPr lang="en-US" dirty="0"/>
+              <a:t> </a:t>
+            </a:r>
+            <a:r>
+              <a:rPr lang="en-US" b="1" dirty="0" err="1"/>
+              <a:t>XGBoost</a:t>
+            </a:r>
+            <a:r>
+              <a:rPr lang="en-US" b="1" dirty="0"/>
+              <a:t> (XGB),</a:t>
+            </a:r>
+            <a:r>
+              <a:rPr lang="en-US" dirty="0"/>
+              <a:t> </a:t>
+            </a:r>
+            <a:r>
+              <a:rPr lang="en-US" b="1" dirty="0" err="1"/>
+              <a:t>LightGBM</a:t>
+            </a:r>
+            <a:r>
+              <a:rPr lang="en-US" b="1" dirty="0"/>
+              <a:t> (LGB),Multi-Layer Perceptron (MLP),</a:t>
+            </a:r>
+            <a:r>
+              <a:rPr lang="en-US" dirty="0"/>
+              <a:t> </a:t>
+            </a:r>
+            <a:r>
+              <a:rPr lang="en-US" b="1" dirty="0"/>
+              <a:t>Logistic Regression (LR)</a:t>
+            </a:r>
+          </a:p>
+          <a:p>
+            <a:endParaRPr lang="en-US" dirty="0"/>
+          </a:p>
+          <a:p>
+            <a:r>
+              <a:rPr lang="en-US" sz="2400" b="1" dirty="0"/>
+              <a:t>Programming Languages</a:t>
+            </a:r>
+          </a:p>
+          <a:p>
+            <a:r>
+              <a:rPr lang="en-US" b="1" dirty="0"/>
+              <a:t>Python 3.11,JavaScript (ES2022)</a:t>
+            </a:r>
+            <a:r>
+              <a:rPr lang="en-US" dirty="0"/>
+              <a:t>,</a:t>
+            </a:r>
+            <a:r>
+              <a:rPr lang="en-US" b="1" dirty="0"/>
+              <a:t>CSS (Vanilla CSS)</a:t>
+            </a:r>
+          </a:p>
+          <a:p>
+            <a:endParaRPr lang="en-US" dirty="0"/>
+          </a:p>
+          <a:p>
+            <a:r>
+              <a:rPr lang="en-US" sz="2400" b="1" dirty="0"/>
+              <a:t>Web Stack</a:t>
+            </a:r>
+          </a:p>
+          <a:p>
+            <a:r>
+              <a:rPr lang="en-US" b="1" dirty="0"/>
+              <a:t>Flask</a:t>
+            </a:r>
+            <a:r>
+              <a:rPr lang="en-US" sz="2400" b="1" dirty="0"/>
+              <a:t>,</a:t>
+            </a:r>
+            <a:r>
+              <a:rPr lang="en-US" b="1" dirty="0"/>
+              <a:t> scikit-learn, pandas, NumPy, </a:t>
+            </a:r>
+            <a:r>
+              <a:rPr lang="en-US" b="1" dirty="0" err="1"/>
+              <a:t>joblib</a:t>
+            </a:r>
+            <a:r>
+              <a:rPr lang="en-US" b="1" dirty="0"/>
+              <a:t>, Matplotlib, React 18, Vite, Recharts </a:t>
+            </a:r>
+            <a:endParaRPr lang="en-US" sz="2400" b="1" dirty="0"/>
+          </a:p>
+          <a:p>
+            <a:endParaRPr lang="en-US" sz="3200" spc="-1" dirty="0">
+              <a:solidFill>
+                <a:srgbClr val="000000"/>
+              </a:solidFill>
+              <a:latin typeface="Gill Sans MT"/>
+            </a:endParaRPr>
+          </a:p>
+          <a:p>
+            <a:pPr marL="536627">
+              <a:spcBef>
+                <a:spcPts val="733"/>
+              </a:spcBef>
+            </a:pPr>
+            <a:endParaRPr lang="en-US" sz="3200" spc="-1" dirty="0">
+              <a:solidFill>
+                <a:srgbClr val="000000"/>
+              </a:solidFill>
+              <a:latin typeface="Gill Sans MT"/>
+            </a:endParaRPr>
+          </a:p>
+          <a:p>
+            <a:pPr marL="109917">
+              <a:spcBef>
+                <a:spcPts val="801"/>
+              </a:spcBef>
+            </a:pPr>
+            <a:endParaRPr lang="en-US" sz="3200" spc="-1" dirty="0">
+              <a:solidFill>
+                <a:srgbClr val="000000"/>
+              </a:solidFill>
+              <a:latin typeface="Gill Sans MT"/>
+            </a:endParaRPr>
+          </a:p>
+        </p:txBody>
+      </p:sp>
+      <p:sp>
+        <p:nvSpPr>
+          <p:cNvPr id="111" name="TextShape 3">
+            <a:extLst>
+              <a:ext uri="{FF2B5EF4-FFF2-40B4-BE49-F238E27FC236}">
+                <a16:creationId xmlns:a16="http://schemas.microsoft.com/office/drawing/2014/main" id="{F4BC6724-9707-184F-3066-39F40243A6B0}"/>
+              </a:ext>
+            </a:extLst>
+          </p:cNvPr>
+          <p:cNvSpPr txBox="1"/>
+          <p:nvPr/>
+        </p:nvSpPr>
+        <p:spPr>
+          <a:xfrm>
+            <a:off x="11484960" y="6305400"/>
+            <a:ext cx="609120" cy="475920"/>
+          </a:xfrm>
+          <a:prstGeom prst="rect">
+            <a:avLst/>
+          </a:prstGeom>
+          <a:noFill/>
+          <a:ln>
+            <a:noFill/>
+          </a:ln>
+        </p:spPr>
+        <p:txBody>
+          <a:bodyPr lIns="120000" tIns="60000" rIns="120000" bIns="60000" anchor="b">
+            <a:noAutofit/>
+          </a:bodyPr>
+          <a:lstStyle/>
+          <a:p>
+            <a:pPr algn="ctr">
+              <a:lnSpc>
+                <a:spcPct val="100000"/>
+              </a:lnSpc>
+            </a:pPr>
+            <a:fld id="{528F5C0C-45A4-465E-8315-A9258DDEFD0F}" type="slidenum">
+              <a:rPr lang="en-IN" sz="1600" spc="-1">
+                <a:solidFill>
+                  <a:srgbClr val="B5A989"/>
+                </a:solidFill>
+                <a:latin typeface="Gill Sans MT"/>
+              </a:rPr>
+              <a:pPr algn="ctr">
+                <a:lnSpc>
+                  <a:spcPct val="100000"/>
+                </a:lnSpc>
+              </a:pPr>
+              <a:t>8</a:t>
+            </a:fld>
+            <a:endParaRPr lang="en-IN" sz="1600" spc="-1">
+              <a:latin typeface="Times New Roman"/>
+            </a:endParaRPr>
+          </a:p>
+        </p:txBody>
+      </p:sp>
+      <p:pic>
+        <p:nvPicPr>
+          <p:cNvPr id="3" name="Picture 2">
+            <a:extLst>
+              <a:ext uri="{FF2B5EF4-FFF2-40B4-BE49-F238E27FC236}">
+                <a16:creationId xmlns:a16="http://schemas.microsoft.com/office/drawing/2014/main" id="{4115297C-41A1-D3DE-E0E5-215AC0FFA2FD}"/>
+              </a:ext>
+            </a:extLst>
+          </p:cNvPr>
+          <p:cNvPicPr>
+            <a:picLocks noChangeAspect="1"/>
+          </p:cNvPicPr>
+          <p:nvPr/>
+        </p:nvPicPr>
+        <p:blipFill>
+          <a:blip r:embed="rId2">
+            <a:extLst>
+              <a:ext uri="{28A0092B-C50C-407E-A947-70E740481C1C}">
+                <a14:useLocalDpi xmlns:a14="http://schemas.microsoft.com/office/drawing/2010/main" val="0"/>
+              </a:ext>
+            </a:extLst>
+          </a:blip>
+          <a:stretch>
+            <a:fillRect/>
+          </a:stretch>
+        </p:blipFill>
+        <p:spPr>
+          <a:xfrm>
+            <a:off x="10032437" y="160201"/>
+            <a:ext cx="2035376" cy="516641"/>
+          </a:xfrm>
+          <a:prstGeom prst="rect">
+            <a:avLst/>
+          </a:prstGeom>
+        </p:spPr>
+      </p:pic>
+    </p:spTree>
+    <p:extLst>
+      <p:ext uri="{BB962C8B-B14F-4D97-AF65-F5344CB8AC3E}">
+        <p14:creationId xmlns:p14="http://schemas.microsoft.com/office/powerpoint/2010/main" val="3267501494"/>
+      </p:ext>
+    </p:extLst>
+  </p:cSld>
+  <p:clrMapOvr>
+    <a:masterClrMapping/>
+  </p:clrMapOvr>
+</p:sld>
+</file>
+
+<file path=ppt/slides/slide9.xml><?xml version="1.0" encoding="utf-8"?>
+<p:sld xmlns:a="http://schemas.openxmlformats.org/drawingml/2006/main" xmlns:r="http://schemas.openxmlformats.org/officeDocument/2006/relationships" xmlns:p="http://schemas.openxmlformats.org/presentationml/2006/main">
+  <p:cSld>
+    <p:spTree>
+      <p:nvGrpSpPr>
+        <p:cNvPr id="1" name="">
+          <a:extLst>
+            <a:ext uri="{FF2B5EF4-FFF2-40B4-BE49-F238E27FC236}">
+              <a16:creationId xmlns:a16="http://schemas.microsoft.com/office/drawing/2014/main" id="{43892C97-F36E-BCB4-699E-2D8162180958}"/>
+            </a:ext>
+          </a:extLst>
+        </p:cNvPr>
+        <p:cNvGrpSpPr/>
+        <p:nvPr/>
+      </p:nvGrpSpPr>
+      <p:grpSpPr>
+        <a:xfrm>
+          <a:off x="0" y="0"/>
+          <a:ext cx="0" cy="0"/>
+          <a:chOff x="0" y="0"/>
+          <a:chExt cx="0" cy="0"/>
+        </a:xfrm>
+      </p:grpSpPr>
+      <p:sp>
+        <p:nvSpPr>
+          <p:cNvPr id="109" name="TextShape 1">
+            <a:extLst>
+              <a:ext uri="{FF2B5EF4-FFF2-40B4-BE49-F238E27FC236}">
+                <a16:creationId xmlns:a16="http://schemas.microsoft.com/office/drawing/2014/main" id="{92160046-EB52-CD90-37C0-AFB11476B9CB}"/>
+              </a:ext>
+            </a:extLst>
+          </p:cNvPr>
+          <p:cNvSpPr txBox="1"/>
+          <p:nvPr/>
+        </p:nvSpPr>
+        <p:spPr>
+          <a:xfrm>
+            <a:off x="279555" y="76681"/>
+            <a:ext cx="11053987" cy="979439"/>
+          </a:xfrm>
+          <a:prstGeom prst="rect">
+            <a:avLst/>
+          </a:prstGeom>
+          <a:noFill/>
+          <a:ln>
+            <a:noFill/>
+          </a:ln>
+        </p:spPr>
+        <p:txBody>
+          <a:bodyPr lIns="120000" tIns="60000" rIns="120000" bIns="60000" anchor="ctr">
+            <a:normAutofit fontScale="40000" lnSpcReduction="20000"/>
+          </a:bodyPr>
+          <a:lstStyle/>
+          <a:p>
+            <a:pPr>
+              <a:lnSpc>
+                <a:spcPct val="100000"/>
+              </a:lnSpc>
+            </a:pPr>
+            <a:br>
+              <a:rPr sz="2400" dirty="0"/>
+            </a:br>
+            <a:r>
+              <a:rPr lang="en-US" sz="7866" b="1" spc="-1" dirty="0">
+                <a:solidFill>
+                  <a:srgbClr val="8A0000"/>
+                </a:solidFill>
+                <a:latin typeface="Calibri" panose="020F0502020204030204" pitchFamily="34" charset="0"/>
+                <a:ea typeface="Calibri" panose="020F0502020204030204" pitchFamily="34" charset="0"/>
+                <a:cs typeface="Calibri" panose="020F0502020204030204" pitchFamily="34" charset="0"/>
+              </a:rPr>
+              <a:t>Simulation and Results</a:t>
+            </a:r>
+            <a:br>
+              <a:rPr lang="en-US" sz="7066" b="1" spc="-1" dirty="0">
+                <a:solidFill>
+                  <a:srgbClr val="8A0000"/>
+                </a:solidFill>
+                <a:latin typeface="Times New Roman" pitchFamily="18" charset="0"/>
+                <a:cs typeface="Times New Roman" pitchFamily="18" charset="0"/>
+              </a:rPr>
+            </a:br>
+            <a:endParaRPr lang="en-US" sz="7066" b="1" spc="-1" dirty="0">
+              <a:solidFill>
+                <a:srgbClr val="8A0000"/>
+              </a:solidFill>
+              <a:latin typeface="Times New Roman" pitchFamily="18" charset="0"/>
+              <a:cs typeface="Times New Roman" pitchFamily="18" charset="0"/>
+            </a:endParaRPr>
+          </a:p>
+        </p:txBody>
+      </p:sp>
+      <p:sp>
+        <p:nvSpPr>
+          <p:cNvPr id="110" name="TextShape 2">
+            <a:extLst>
+              <a:ext uri="{FF2B5EF4-FFF2-40B4-BE49-F238E27FC236}">
+                <a16:creationId xmlns:a16="http://schemas.microsoft.com/office/drawing/2014/main" id="{7F3FF00A-8B20-B862-1391-CAE97E4165AE}"/>
+              </a:ext>
+            </a:extLst>
+          </p:cNvPr>
+          <p:cNvSpPr txBox="1"/>
+          <p:nvPr/>
+        </p:nvSpPr>
+        <p:spPr>
+          <a:xfrm>
+            <a:off x="305820" y="740701"/>
+            <a:ext cx="11193400" cy="4812680"/>
+          </a:xfrm>
+          <a:prstGeom prst="rect">
+            <a:avLst/>
+          </a:prstGeom>
+          <a:noFill/>
+          <a:ln>
+            <a:noFill/>
+          </a:ln>
+        </p:spPr>
+        <p:txBody>
+          <a:bodyPr lIns="120000" tIns="60000" rIns="120000" bIns="60000">
+            <a:noAutofit/>
+          </a:bodyPr>
+          <a:lstStyle/>
+          <a:p>
+            <a:pPr marL="384710" indent="-457189">
+              <a:spcBef>
+                <a:spcPts val="733"/>
+              </a:spcBef>
+              <a:buClr>
+                <a:srgbClr val="C00000"/>
+              </a:buClr>
+              <a:buFont typeface="Wingdings" panose="05000000000000000000" pitchFamily="2" charset="2"/>
+              <a:buChar char="q"/>
+            </a:pPr>
+            <a:r>
+              <a:rPr lang="en-US" sz="2667" b="1" spc="-1" dirty="0">
+                <a:solidFill>
+                  <a:srgbClr val="000000"/>
+                </a:solidFill>
+                <a:latin typeface="Calibri" panose="020F0502020204030204" pitchFamily="34" charset="0"/>
+                <a:ea typeface="Calibri" panose="020F0502020204030204" pitchFamily="34" charset="0"/>
+                <a:cs typeface="Calibri" panose="020F0502020204030204" pitchFamily="34" charset="0"/>
+              </a:rPr>
+              <a:t>Dataset Descriptions / Input – Output Descriptions</a:t>
+            </a:r>
+          </a:p>
+          <a:p>
+            <a:r>
+              <a:rPr lang="en-US" dirty="0"/>
+              <a:t>The system is trained and evaluated on the </a:t>
+            </a:r>
+            <a:r>
+              <a:rPr lang="en-US" b="1" dirty="0"/>
+              <a:t>UNSW-NB15</a:t>
+            </a:r>
+            <a:r>
+              <a:rPr lang="en-US" dirty="0"/>
+              <a:t> dataset, a modern cyber-security benchmark released in 2015 by the Australian Centre for Cyber Security (ACCS) at the University of New South Wales:</a:t>
+            </a:r>
+          </a:p>
+          <a:p>
+            <a:r>
+              <a:rPr lang="en-US" b="1" dirty="0"/>
+              <a:t>Classification Task</a:t>
+            </a:r>
+            <a:r>
+              <a:rPr lang="en-US" dirty="0"/>
+              <a:t>: Binary classification (Normal vs. Attack).</a:t>
+            </a:r>
+          </a:p>
+          <a:p>
+            <a:r>
+              <a:rPr lang="en-US" b="1" dirty="0"/>
+              <a:t>Target Classes</a:t>
+            </a:r>
+            <a:r>
+              <a:rPr lang="en-US" dirty="0"/>
+              <a:t>:</a:t>
+            </a:r>
+          </a:p>
+          <a:p>
+            <a:pPr lvl="1"/>
+            <a:r>
+              <a:rPr lang="en-US" b="1" dirty="0"/>
+              <a:t>0 (Normal)</a:t>
+            </a:r>
+            <a:r>
+              <a:rPr lang="en-US" dirty="0"/>
+              <a:t>: Legitimate, benign background network traffic.</a:t>
+            </a:r>
+          </a:p>
+          <a:p>
+            <a:pPr lvl="1"/>
+            <a:r>
+              <a:rPr lang="en-US" b="1" dirty="0"/>
+              <a:t>1 (Attack)</a:t>
+            </a:r>
+            <a:r>
+              <a:rPr lang="en-US" dirty="0"/>
+              <a:t>: Network intrusions spanning 9 main categories (Denial of Service, Exploits, Reconnaissance, </a:t>
+            </a:r>
+            <a:r>
+              <a:rPr lang="en-US" dirty="0" err="1"/>
+              <a:t>Fuzzers</a:t>
+            </a:r>
+            <a:r>
+              <a:rPr lang="en-US" dirty="0"/>
+              <a:t>, Worms, Shellcode, Backdoors, Generic, and Analysis). These categories are merged into a single </a:t>
+            </a:r>
+            <a:r>
+              <a:rPr lang="en-US" i="1" dirty="0"/>
+              <a:t>Attack</a:t>
+            </a:r>
+            <a:r>
+              <a:rPr lang="en-US" dirty="0"/>
+              <a:t> class for model training.</a:t>
+            </a:r>
+          </a:p>
+          <a:p>
+            <a:r>
+              <a:rPr lang="en-US" b="1" dirty="0"/>
+              <a:t>Dataset Splits</a:t>
+            </a:r>
+            <a:r>
+              <a:rPr lang="en-US" dirty="0"/>
+              <a:t>:</a:t>
+            </a:r>
+          </a:p>
+          <a:p>
+            <a:pPr lvl="1"/>
+            <a:r>
+              <a:rPr lang="en-US" b="1" dirty="0"/>
+              <a:t>Training Split</a:t>
+            </a:r>
+            <a:r>
+              <a:rPr lang="en-US" dirty="0"/>
+              <a:t>: 175,341 records (56,000 Normal, 119,341 Attack).</a:t>
+            </a:r>
+          </a:p>
+          <a:p>
+            <a:pPr lvl="1"/>
+            <a:r>
+              <a:rPr lang="en-US" b="1" dirty="0"/>
+              <a:t>Test Split</a:t>
+            </a:r>
+            <a:r>
+              <a:rPr lang="en-US" dirty="0"/>
+              <a:t>: 82,332 records (37,000 Normal, 45,332 Attack).</a:t>
+            </a:r>
+          </a:p>
+          <a:p>
+            <a:br>
+              <a:rPr lang="en-US" dirty="0"/>
+            </a:br>
+            <a:endParaRPr lang="en-US" sz="2667" b="1" spc="-1" dirty="0">
+              <a:solidFill>
+                <a:srgbClr val="000000"/>
+              </a:solidFill>
+              <a:latin typeface="Calibri" panose="020F0502020204030204" pitchFamily="34" charset="0"/>
+              <a:ea typeface="Calibri" panose="020F0502020204030204" pitchFamily="34" charset="0"/>
+              <a:cs typeface="Calibri" panose="020F0502020204030204" pitchFamily="34" charset="0"/>
+            </a:endParaRPr>
+          </a:p>
+          <a:p>
+            <a:endParaRPr lang="en-US" sz="3200" spc="-1" dirty="0">
+              <a:solidFill>
+                <a:srgbClr val="000000"/>
+              </a:solidFill>
+              <a:latin typeface="Gill Sans MT"/>
+            </a:endParaRPr>
+          </a:p>
+          <a:p>
+            <a:endParaRPr lang="en-US" sz="3200" spc="-1" dirty="0">
+              <a:solidFill>
+                <a:srgbClr val="000000"/>
+              </a:solidFill>
+              <a:latin typeface="Gill Sans MT"/>
+            </a:endParaRPr>
+          </a:p>
+          <a:p>
+            <a:pPr marL="536627">
+              <a:spcBef>
+                <a:spcPts val="733"/>
+              </a:spcBef>
+            </a:pPr>
+            <a:endParaRPr lang="en-US" sz="3200" spc="-1" dirty="0">
+              <a:solidFill>
+                <a:srgbClr val="000000"/>
+              </a:solidFill>
+              <a:latin typeface="Gill Sans MT"/>
+            </a:endParaRPr>
+          </a:p>
+          <a:p>
+            <a:pPr marL="109917">
+              <a:spcBef>
+                <a:spcPts val="801"/>
+              </a:spcBef>
+            </a:pPr>
+            <a:endParaRPr lang="en-US" sz="3200" spc="-1" dirty="0">
+              <a:solidFill>
+                <a:srgbClr val="000000"/>
+              </a:solidFill>
+              <a:latin typeface="Gill Sans MT"/>
+            </a:endParaRPr>
+          </a:p>
+        </p:txBody>
+      </p:sp>
+      <p:sp>
+        <p:nvSpPr>
+          <p:cNvPr id="111" name="TextShape 3">
+            <a:extLst>
+              <a:ext uri="{FF2B5EF4-FFF2-40B4-BE49-F238E27FC236}">
+                <a16:creationId xmlns:a16="http://schemas.microsoft.com/office/drawing/2014/main" id="{64EDF79D-8D5B-6AFF-0EA3-42D35D8BD3BA}"/>
+              </a:ext>
+            </a:extLst>
+          </p:cNvPr>
+          <p:cNvSpPr txBox="1"/>
+          <p:nvPr/>
+        </p:nvSpPr>
+        <p:spPr>
+          <a:xfrm>
+            <a:off x="11484960" y="6305400"/>
+            <a:ext cx="609120" cy="475920"/>
+          </a:xfrm>
+          <a:prstGeom prst="rect">
+            <a:avLst/>
+          </a:prstGeom>
+          <a:noFill/>
+          <a:ln>
+            <a:noFill/>
+          </a:ln>
+        </p:spPr>
+        <p:txBody>
+          <a:bodyPr lIns="120000" tIns="60000" rIns="120000" bIns="60000" anchor="b">
+            <a:noAutofit/>
+          </a:bodyPr>
+          <a:lstStyle/>
+          <a:p>
+            <a:pPr algn="ctr">
+              <a:lnSpc>
+                <a:spcPct val="100000"/>
+              </a:lnSpc>
+            </a:pPr>
+            <a:fld id="{528F5C0C-45A4-465E-8315-A9258DDEFD0F}" type="slidenum">
+              <a:rPr lang="en-IN" sz="1600" spc="-1">
+                <a:solidFill>
+                  <a:srgbClr val="B5A989"/>
+                </a:solidFill>
+                <a:latin typeface="Gill Sans MT"/>
+              </a:rPr>
+              <a:pPr algn="ctr">
+                <a:lnSpc>
+                  <a:spcPct val="100000"/>
+                </a:lnSpc>
+              </a:pPr>
+              <a:t>9</a:t>
+            </a:fld>
+            <a:endParaRPr lang="en-IN" sz="1600" spc="-1">
+              <a:latin typeface="Times New Roman"/>
+            </a:endParaRPr>
+          </a:p>
+        </p:txBody>
+      </p:sp>
+      <p:pic>
+        <p:nvPicPr>
+          <p:cNvPr id="3" name="Picture 2">
+            <a:extLst>
+              <a:ext uri="{FF2B5EF4-FFF2-40B4-BE49-F238E27FC236}">
+                <a16:creationId xmlns:a16="http://schemas.microsoft.com/office/drawing/2014/main" id="{7D629E7A-873F-C14D-0B20-4F447B950407}"/>
+              </a:ext>
+            </a:extLst>
+          </p:cNvPr>
+          <p:cNvPicPr>
+            <a:picLocks noChangeAspect="1"/>
+          </p:cNvPicPr>
+          <p:nvPr/>
+        </p:nvPicPr>
+        <p:blipFill>
+          <a:blip r:embed="rId2">
+            <a:extLst>
+              <a:ext uri="{28A0092B-C50C-407E-A947-70E740481C1C}">
+                <a14:useLocalDpi xmlns:a14="http://schemas.microsoft.com/office/drawing/2010/main" val="0"/>
+              </a:ext>
+            </a:extLst>
+          </a:blip>
+          <a:stretch>
+            <a:fillRect/>
+          </a:stretch>
+        </p:blipFill>
+        <p:spPr>
+          <a:xfrm>
+            <a:off x="10032437" y="160201"/>
+            <a:ext cx="2035376" cy="516641"/>
+          </a:xfrm>
+          <a:prstGeom prst="rect">
+            <a:avLst/>
+          </a:prstGeom>
+        </p:spPr>
+      </p:pic>
+    </p:spTree>
+    <p:extLst>
+      <p:ext uri="{BB962C8B-B14F-4D97-AF65-F5344CB8AC3E}">
+        <p14:creationId xmlns:p14="http://schemas.microsoft.com/office/powerpoint/2010/main" val="1393089956"/>
       </p:ext>
     </p:extLst>
   </p:cSld>

</xml_diff>